<commit_message>
Update labs to Questa
Thanks Dr. Sharma for the big lift getting this done!
</commit_message>
<xml_diff>
--- a/Laboratory Latex/Lab01SimpleVerilog/LMS Upload Lab01/Lab01 presentation.pptx
+++ b/Laboratory Latex/Lab01SimpleVerilog/LMS Upload Lab01/Lab01 presentation.pptx
@@ -2,24 +2,28 @@
 <file path=ppt/presentation.xml><?xml version="1.0" encoding="utf-8"?>
 <p:presentation xmlns:a="http://schemas.openxmlformats.org/drawingml/2006/main" xmlns:r="http://schemas.openxmlformats.org/officeDocument/2006/relationships" xmlns:p="http://schemas.openxmlformats.org/presentationml/2006/main" saveSubsetFonts="1" autoCompressPictures="0">
   <p:sldMasterIdLst>
-    <p:sldMasterId id="2147483648" r:id="rId1"/>
+    <p:sldMasterId id="2147483648" r:id="rId4"/>
   </p:sldMasterIdLst>
   <p:notesMasterIdLst>
-    <p:notesMasterId r:id="rId11"/>
+    <p:notesMasterId r:id="rId18"/>
   </p:notesMasterIdLst>
   <p:handoutMasterIdLst>
-    <p:handoutMasterId r:id="rId12"/>
+    <p:handoutMasterId r:id="rId19"/>
   </p:handoutMasterIdLst>
   <p:sldIdLst>
-    <p:sldId id="262" r:id="rId2"/>
-    <p:sldId id="538" r:id="rId3"/>
-    <p:sldId id="626" r:id="rId4"/>
-    <p:sldId id="625" r:id="rId5"/>
-    <p:sldId id="557" r:id="rId6"/>
-    <p:sldId id="621" r:id="rId7"/>
-    <p:sldId id="622" r:id="rId8"/>
-    <p:sldId id="623" r:id="rId9"/>
-    <p:sldId id="624" r:id="rId10"/>
+    <p:sldId id="262" r:id="rId5"/>
+    <p:sldId id="625" r:id="rId6"/>
+    <p:sldId id="632" r:id="rId7"/>
+    <p:sldId id="637" r:id="rId8"/>
+    <p:sldId id="557" r:id="rId9"/>
+    <p:sldId id="621" r:id="rId10"/>
+    <p:sldId id="622" r:id="rId11"/>
+    <p:sldId id="623" r:id="rId12"/>
+    <p:sldId id="624" r:id="rId13"/>
+    <p:sldId id="634" r:id="rId14"/>
+    <p:sldId id="636" r:id="rId15"/>
+    <p:sldId id="627" r:id="rId16"/>
+    <p:sldId id="633" r:id="rId17"/>
   </p:sldIdLst>
   <p:sldSz cx="12192000" cy="6858000"/>
   <p:notesSz cx="6858000" cy="9144000"/>
@@ -129,6 +133,43 @@
 </p:presentation>
 </file>
 
+<file path=ppt/revisionInfo.xml><?xml version="1.0" encoding="utf-8"?>
+<p1510:revInfo xmlns:a="http://schemas.openxmlformats.org/drawingml/2006/main" xmlns:r="http://schemas.openxmlformats.org/officeDocument/2006/relationships" xmlns:p1510="http://schemas.microsoft.com/office/powerpoint/2015/10/main">
+  <p1510:revLst>
+    <p1510:client id="{7867D606-A8B9-AC0F-9577-6E06F078A971}" v="5" dt="2025-08-26T02:01:06.801"/>
+  </p1510:revLst>
+</p1510:revInfo>
+</file>
+
+<file path=ppt/changesInfos/changesInfo1.xml><?xml version="1.0" encoding="utf-8"?>
+<pc:chgInfo xmlns:a="http://schemas.openxmlformats.org/drawingml/2006/main" xmlns:r="http://schemas.openxmlformats.org/officeDocument/2006/relationships" xmlns:ac="http://schemas.microsoft.com/office/drawing/2013/main/command" xmlns:pc="http://schemas.microsoft.com/office/powerpoint/2013/main/command">
+  <pc:docChgLst>
+    <pc:chgData name="Ben Sitanggang (Student)" userId="S::ben_sitanggang@mines.edu::c5671cab-f65a-4798-8726-9481ce874815" providerId="AD" clId="Web-{7867D606-A8B9-AC0F-9577-6E06F078A971}"/>
+    <pc:docChg chg="modSld">
+      <pc:chgData name="Ben Sitanggang (Student)" userId="S::ben_sitanggang@mines.edu::c5671cab-f65a-4798-8726-9481ce874815" providerId="AD" clId="Web-{7867D606-A8B9-AC0F-9577-6E06F078A971}" dt="2025-08-26T02:01:06.004" v="3" actId="20577"/>
+      <pc:docMkLst>
+        <pc:docMk/>
+      </pc:docMkLst>
+      <pc:sldChg chg="modSp">
+        <pc:chgData name="Ben Sitanggang (Student)" userId="S::ben_sitanggang@mines.edu::c5671cab-f65a-4798-8726-9481ce874815" providerId="AD" clId="Web-{7867D606-A8B9-AC0F-9577-6E06F078A971}" dt="2025-08-26T02:01:06.004" v="3" actId="20577"/>
+        <pc:sldMkLst>
+          <pc:docMk/>
+          <pc:sldMk cId="4103412256" sldId="632"/>
+        </pc:sldMkLst>
+        <pc:spChg chg="mod">
+          <ac:chgData name="Ben Sitanggang (Student)" userId="S::ben_sitanggang@mines.edu::c5671cab-f65a-4798-8726-9481ce874815" providerId="AD" clId="Web-{7867D606-A8B9-AC0F-9577-6E06F078A971}" dt="2025-08-26T02:01:06.004" v="3" actId="20577"/>
+          <ac:spMkLst>
+            <pc:docMk/>
+            <pc:sldMk cId="4103412256" sldId="632"/>
+            <ac:spMk id="3" creationId="{5F734E9C-AAA0-10DE-BFCE-49D582275CBC}"/>
+          </ac:spMkLst>
+        </pc:spChg>
+      </pc:sldChg>
+    </pc:docChg>
+  </pc:docChgLst>
+</pc:chgInfo>
+</file>
+
 <file path=ppt/handoutMasters/handoutMaster1.xml><?xml version="1.0" encoding="utf-8"?>
 <p:handoutMaster xmlns:a="http://schemas.openxmlformats.org/drawingml/2006/main" xmlns:r="http://schemas.openxmlformats.org/officeDocument/2006/relationships" xmlns:p="http://schemas.openxmlformats.org/presentationml/2006/main">
   <p:cSld>
@@ -211,7 +252,7 @@
           <a:p>
             <a:fld id="{E4DD5C9C-88A3-CA43-B162-DCC4E1E4BE7D}" type="datetimeFigureOut">
               <a:rPr lang="en-US" smtClean="0"/>
-              <a:t>1/22/2024</a:t>
+              <a:t>1/18/2026</a:t>
             </a:fld>
             <a:endParaRPr lang="en-US"/>
           </a:p>
@@ -376,7 +417,7 @@
           <a:p>
             <a:fld id="{BC5E4000-89B6-4F22-834E-B172C4AA57D1}" type="datetimeFigureOut">
               <a:rPr lang="en-US" smtClean="0"/>
-              <a:t>1/22/2024</a:t>
+              <a:t>1/18/2026</a:t>
             </a:fld>
             <a:endParaRPr lang="en-US"/>
           </a:p>
@@ -687,10 +728,7 @@
           <a:bodyPr/>
           <a:lstStyle/>
           <a:p>
-            <a:r>
-              <a:rPr lang="en-US" dirty="0"/>
-              <a:t>Usually the &lt;title of the lab&gt; is what will be called the “System” through the rest of this document</a:t>
-            </a:r>
+            <a:endParaRPr lang="en-US"/>
           </a:p>
         </p:txBody>
       </p:sp>
@@ -781,7 +819,7 @@
           </a:bodyPr>
           <a:lstStyle/>
           <a:p>
-            <a:endParaRPr lang="en-US" dirty="0"/>
+            <a:endParaRPr lang="en-US"/>
           </a:p>
         </p:txBody>
       </p:sp>
@@ -815,6 +853,11 @@
         </p:txBody>
       </p:sp>
     </p:spTree>
+    <p:extLst>
+      <p:ext uri="{BB962C8B-B14F-4D97-AF65-F5344CB8AC3E}">
+        <p14:creationId xmlns:p14="http://schemas.microsoft.com/office/powerpoint/2010/main" val="2317861748"/>
+      </p:ext>
+    </p:extLst>
   </p:cSld>
   <p:clrMapOvr>
     <a:masterClrMapping/>
@@ -849,12 +892,7 @@
             <p:ph type="sldImg"/>
           </p:nvPr>
         </p:nvSpPr>
-        <p:spPr>
-          <a:xfrm>
-            <a:off x="457200" y="720725"/>
-            <a:ext cx="6400800" cy="3600450"/>
-          </a:xfrm>
-        </p:spPr>
+        <p:spPr/>
       </p:sp>
       <p:sp>
         <p:nvSpPr>
@@ -868,12 +906,10 @@
         </p:nvSpPr>
         <p:spPr/>
         <p:txBody>
-          <a:bodyPr>
-            <a:normAutofit/>
-          </a:bodyPr>
-          <a:lstStyle/>
-          <a:p>
-            <a:endParaRPr lang="en-US" dirty="0"/>
+          <a:bodyPr/>
+          <a:lstStyle/>
+          <a:p>
+            <a:endParaRPr lang="en-US"/>
           </a:p>
         </p:txBody>
       </p:sp>
@@ -884,7 +920,7 @@
             <a:spLocks noGrp="1"/>
           </p:cNvSpPr>
           <p:nvPr>
-            <p:ph type="sldNum" sz="quarter" idx="10"/>
+            <p:ph type="sldNum" sz="quarter" idx="5"/>
           </p:nvPr>
         </p:nvSpPr>
         <p:spPr/>
@@ -892,15 +928,9 @@
           <a:bodyPr/>
           <a:lstStyle/>
           <a:p>
-            <a:pPr>
-              <a:defRPr/>
-            </a:pPr>
-            <a:fld id="{AD45CC39-578B-4552-A24A-45E58858BC64}" type="slidenum">
+            <a:fld id="{AA0C4D68-66B1-48D6-AAFD-4ABFAB720F6F}" type="slidenum">
               <a:rPr lang="en-US" smtClean="0"/>
-              <a:pPr>
-                <a:defRPr/>
-              </a:pPr>
-              <a:t>4</a:t>
+              <a:t>3</a:t>
             </a:fld>
             <a:endParaRPr lang="en-US"/>
           </a:p>
@@ -909,7 +939,7 @@
     </p:spTree>
     <p:extLst>
       <p:ext uri="{BB962C8B-B14F-4D97-AF65-F5344CB8AC3E}">
-        <p14:creationId xmlns:p14="http://schemas.microsoft.com/office/powerpoint/2010/main" val="2317861748"/>
+        <p14:creationId xmlns:p14="http://schemas.microsoft.com/office/powerpoint/2010/main" val="1172761048"/>
       </p:ext>
     </p:extLst>
   </p:cSld>
@@ -963,10 +993,7 @@
           <a:bodyPr/>
           <a:lstStyle/>
           <a:p>
-            <a:r>
-              <a:rPr lang="en-US" dirty="0"/>
-              <a:t>Replace &lt;System&gt; with the name of the </a:t>
-            </a:r>
+            <a:endParaRPr lang="en-US"/>
           </a:p>
         </p:txBody>
       </p:sp>
@@ -1050,10 +1077,7 @@
           <a:bodyPr/>
           <a:lstStyle/>
           <a:p>
-            <a:r>
-              <a:rPr lang="en-US" dirty="0"/>
-              <a:t>Replace &lt;System&gt; with the name of the </a:t>
-            </a:r>
+            <a:endParaRPr lang="en-US"/>
           </a:p>
         </p:txBody>
       </p:sp>
@@ -1137,10 +1161,7 @@
           <a:bodyPr/>
           <a:lstStyle/>
           <a:p>
-            <a:r>
-              <a:rPr lang="en-US" dirty="0"/>
-              <a:t>Replace &lt;System&gt; with the name of the </a:t>
-            </a:r>
+            <a:endParaRPr lang="en-US"/>
           </a:p>
         </p:txBody>
       </p:sp>
@@ -1224,10 +1245,7 @@
           <a:bodyPr/>
           <a:lstStyle/>
           <a:p>
-            <a:r>
-              <a:rPr lang="en-US" dirty="0"/>
-              <a:t>Replace &lt;System&gt; with the name of the </a:t>
-            </a:r>
+            <a:endParaRPr lang="en-US"/>
           </a:p>
         </p:txBody>
       </p:sp>
@@ -1311,10 +1329,7 @@
           <a:bodyPr/>
           <a:lstStyle/>
           <a:p>
-            <a:r>
-              <a:rPr lang="en-US" dirty="0"/>
-              <a:t>Replace &lt;System&gt; with the name of the </a:t>
-            </a:r>
+            <a:endParaRPr lang="en-US"/>
           </a:p>
         </p:txBody>
       </p:sp>
@@ -1345,6 +1360,127 @@
     <p:extLst>
       <p:ext uri="{BB962C8B-B14F-4D97-AF65-F5344CB8AC3E}">
         <p14:creationId xmlns:p14="http://schemas.microsoft.com/office/powerpoint/2010/main" val="1312227456"/>
+      </p:ext>
+    </p:extLst>
+  </p:cSld>
+  <p:clrMapOvr>
+    <a:masterClrMapping/>
+  </p:clrMapOvr>
+</p:notes>
+</file>
+
+<file path=ppt/notesSlides/notesSlide9.xml><?xml version="1.0" encoding="utf-8"?>
+<p:notes xmlns:a="http://schemas.openxmlformats.org/drawingml/2006/main" xmlns:r="http://schemas.openxmlformats.org/officeDocument/2006/relationships" xmlns:p="http://schemas.openxmlformats.org/presentationml/2006/main">
+  <p:cSld>
+    <p:spTree>
+      <p:nvGrpSpPr>
+        <p:cNvPr id="1" name=""/>
+        <p:cNvGrpSpPr/>
+        <p:nvPr/>
+      </p:nvGrpSpPr>
+      <p:grpSpPr>
+        <a:xfrm>
+          <a:off x="0" y="0"/>
+          <a:ext cx="0" cy="0"/>
+          <a:chOff x="0" y="0"/>
+          <a:chExt cx="0" cy="0"/>
+        </a:xfrm>
+      </p:grpSpPr>
+      <p:sp>
+        <p:nvSpPr>
+          <p:cNvPr id="2" name="Slide Image Placeholder 1"/>
+          <p:cNvSpPr>
+            <a:spLocks noGrp="1" noRot="1" noChangeAspect="1"/>
+          </p:cNvSpPr>
+          <p:nvPr>
+            <p:ph type="sldImg"/>
+          </p:nvPr>
+        </p:nvSpPr>
+        <p:spPr/>
+      </p:sp>
+      <p:sp>
+        <p:nvSpPr>
+          <p:cNvPr id="3" name="Notes Placeholder 2"/>
+          <p:cNvSpPr>
+            <a:spLocks noGrp="1"/>
+          </p:cNvSpPr>
+          <p:nvPr>
+            <p:ph type="body" idx="1"/>
+          </p:nvPr>
+        </p:nvSpPr>
+        <p:spPr/>
+        <p:txBody>
+          <a:bodyPr/>
+          <a:lstStyle/>
+          <a:p>
+            <a:pPr marL="0" marR="0" lvl="0" indent="0" algn="l" defTabSz="914400" rtl="0" eaLnBrk="1" fontAlgn="auto" latinLnBrk="0" hangingPunct="1">
+              <a:lnSpc>
+                <a:spcPct val="100000"/>
+              </a:lnSpc>
+              <a:spcBef>
+                <a:spcPts val="0"/>
+              </a:spcBef>
+              <a:spcAft>
+                <a:spcPts val="0"/>
+              </a:spcAft>
+              <a:buClrTx/>
+              <a:buSzTx/>
+              <a:buFontTx/>
+              <a:buNone/>
+              <a:tabLst/>
+              <a:defRPr/>
+            </a:pPr>
+            <a:r>
+              <a:rPr lang="en-US"/>
+              <a:t>As we recently had version 24.1 installed, it might not show up in search as the top choice. Make sure you type ‘</a:t>
+            </a:r>
+            <a:r>
+              <a:rPr lang="en-US" err="1"/>
+              <a:t>quartus</a:t>
+            </a:r>
+            <a:r>
+              <a:rPr lang="en-US"/>
+              <a:t> prime’ in the search option to see the latest version. Also, do not chose the programmer, you want to launch the executable app that you can recognize by the blue icon </a:t>
+            </a:r>
+          </a:p>
+          <a:p>
+            <a:endParaRPr lang="en-US"/>
+          </a:p>
+          <a:p>
+            <a:r>
+              <a:rPr lang="en-US"/>
+              <a:t>This might only happen the first few times till the cache is updated and 24.1 starts showing up as a top choice in the search options </a:t>
+            </a:r>
+          </a:p>
+        </p:txBody>
+      </p:sp>
+      <p:sp>
+        <p:nvSpPr>
+          <p:cNvPr id="4" name="Slide Number Placeholder 3"/>
+          <p:cNvSpPr>
+            <a:spLocks noGrp="1"/>
+          </p:cNvSpPr>
+          <p:nvPr>
+            <p:ph type="sldNum" sz="quarter" idx="5"/>
+          </p:nvPr>
+        </p:nvSpPr>
+        <p:spPr/>
+        <p:txBody>
+          <a:bodyPr/>
+          <a:lstStyle/>
+          <a:p>
+            <a:fld id="{AA0C4D68-66B1-48D6-AAFD-4ABFAB720F6F}" type="slidenum">
+              <a:rPr lang="en-US" smtClean="0"/>
+              <a:t>13</a:t>
+            </a:fld>
+            <a:endParaRPr lang="en-US"/>
+          </a:p>
+        </p:txBody>
+      </p:sp>
+    </p:spTree>
+    <p:extLst>
+      <p:ext uri="{BB962C8B-B14F-4D97-AF65-F5344CB8AC3E}">
+        <p14:creationId xmlns:p14="http://schemas.microsoft.com/office/powerpoint/2010/main" val="1278637845"/>
       </p:ext>
     </p:extLst>
   </p:cSld>
@@ -1427,7 +1563,7 @@
           <a:p>
             <a:fld id="{8923E60E-3077-9A4D-B784-FBCD6B1A2E3F}" type="datetimeFigureOut">
               <a:rPr lang="en-US" smtClean="0"/>
-              <a:t>1/22/2024</a:t>
+              <a:t>1/18/2026</a:t>
             </a:fld>
             <a:endParaRPr lang="en-US"/>
           </a:p>
@@ -1478,7 +1614,7 @@
           <a:lstStyle/>
           <a:p>
             <a:pPr algn="ctr"/>
-            <a:endParaRPr lang="en-US" sz="1800" dirty="0"/>
+            <a:endParaRPr lang="en-US" sz="1800"/>
           </a:p>
         </p:txBody>
       </p:sp>
@@ -1505,7 +1641,7 @@
           <a:bodyPr/>
           <a:lstStyle/>
           <a:p>
-            <a:endParaRPr lang="en-US" dirty="0"/>
+            <a:endParaRPr lang="en-US"/>
           </a:p>
         </p:txBody>
       </p:sp>
@@ -1643,7 +1779,7 @@
           <a:p>
             <a:pPr algn="r"/>
             <a:r>
-              <a:rPr lang="en-US" sz="1800" b="1" i="0" dirty="0">
+              <a:rPr lang="en-US" sz="1800" b="1" i="0">
                 <a:solidFill>
                   <a:srgbClr val="21314D"/>
                 </a:solidFill>
@@ -1654,7 +1790,7 @@
               <a:t>MINES</a:t>
             </a:r>
             <a:r>
-              <a:rPr lang="en-US" sz="1800" b="1" i="0" dirty="0">
+              <a:rPr lang="en-US" sz="1800" b="1" i="0">
                 <a:solidFill>
                   <a:srgbClr val="D2492A"/>
                 </a:solidFill>
@@ -1665,7 +1801,7 @@
               <a:t>.</a:t>
             </a:r>
             <a:r>
-              <a:rPr lang="en-US" sz="1800" b="0" i="0" dirty="0">
+              <a:rPr lang="en-US" sz="1800" b="0" i="0">
                 <a:solidFill>
                   <a:srgbClr val="92A2BD"/>
                 </a:solidFill>
@@ -1712,7 +1848,7 @@
           <a:p>
             <a:pPr algn="l"/>
             <a:r>
-              <a:rPr lang="en-US" dirty="0">
+              <a:rPr lang="en-US">
                 <a:solidFill>
                   <a:schemeClr val="bg1"/>
                 </a:solidFill>
@@ -1794,7 +1930,7 @@
           <a:p>
             <a:pPr algn="l"/>
             <a:r>
-              <a:rPr lang="en-US" sz="5400" dirty="0">
+              <a:rPr lang="en-US" sz="5400">
                 <a:solidFill>
                   <a:schemeClr val="bg1"/>
                 </a:solidFill>
@@ -1863,7 +1999,7 @@
           </a:lstStyle>
           <a:p>
             <a:r>
-              <a:rPr lang="en-US" dirty="0"/>
+              <a:rPr lang="en-US"/>
               <a:t>Click to edit Master title style</a:t>
             </a:r>
           </a:p>
@@ -1919,35 +2055,35 @@
           <a:p>
             <a:pPr lvl="0"/>
             <a:r>
-              <a:rPr lang="en-US" dirty="0"/>
+              <a:rPr lang="en-US"/>
               <a:t>Click to edit Master text styles</a:t>
             </a:r>
           </a:p>
           <a:p>
             <a:pPr lvl="1"/>
             <a:r>
-              <a:rPr lang="en-US" dirty="0"/>
+              <a:rPr lang="en-US"/>
               <a:t>Second level</a:t>
             </a:r>
           </a:p>
           <a:p>
             <a:pPr lvl="2"/>
             <a:r>
-              <a:rPr lang="en-US" dirty="0"/>
+              <a:rPr lang="en-US"/>
               <a:t>Third level</a:t>
             </a:r>
           </a:p>
           <a:p>
             <a:pPr lvl="3"/>
             <a:r>
-              <a:rPr lang="en-US" dirty="0"/>
+              <a:rPr lang="en-US"/>
               <a:t>Fourth level</a:t>
             </a:r>
           </a:p>
           <a:p>
             <a:pPr lvl="4"/>
             <a:r>
-              <a:rPr lang="en-US" dirty="0"/>
+              <a:rPr lang="en-US"/>
               <a:t>Fifth level</a:t>
             </a:r>
           </a:p>
@@ -2012,7 +2148,7 @@
           <a:p>
             <a:pPr lvl="0"/>
             <a:r>
-              <a:rPr lang="en-US" dirty="0"/>
+              <a:rPr lang="en-US"/>
               <a:t>Click to edit Master text styles</a:t>
             </a:r>
           </a:p>
@@ -2043,7 +2179,7 @@
           <a:p>
             <a:fld id="{8923E60E-3077-9A4D-B784-FBCD6B1A2E3F}" type="datetimeFigureOut">
               <a:rPr lang="en-US" smtClean="0"/>
-              <a:t>1/22/2024</a:t>
+              <a:t>1/18/2026</a:t>
             </a:fld>
             <a:endParaRPr lang="en-US"/>
           </a:p>
@@ -2146,7 +2282,7 @@
           <a:lstStyle/>
           <a:p>
             <a:pPr algn="ctr"/>
-            <a:endParaRPr lang="en-US" sz="1800" dirty="0"/>
+            <a:endParaRPr lang="en-US" sz="1800"/>
           </a:p>
         </p:txBody>
       </p:sp>
@@ -2180,7 +2316,7 @@
           <a:p>
             <a:pPr algn="r"/>
             <a:r>
-              <a:rPr lang="en-US" sz="1800" b="1" i="0" dirty="0">
+              <a:rPr lang="en-US" sz="1800" b="1" i="0">
                 <a:solidFill>
                   <a:schemeClr val="bg1"/>
                 </a:solidFill>
@@ -2191,7 +2327,7 @@
               <a:t>MINES</a:t>
             </a:r>
             <a:r>
-              <a:rPr lang="en-US" sz="1800" b="1" i="0" dirty="0">
+              <a:rPr lang="en-US" sz="1800" b="1" i="0">
                 <a:solidFill>
                   <a:srgbClr val="D2492A"/>
                 </a:solidFill>
@@ -2202,7 +2338,7 @@
               <a:t>.</a:t>
             </a:r>
             <a:r>
-              <a:rPr lang="en-US" sz="1800" b="0" i="0" dirty="0">
+              <a:rPr lang="en-US" sz="1800" b="0" i="0">
                 <a:solidFill>
                   <a:srgbClr val="92A2BD"/>
                 </a:solidFill>
@@ -2321,7 +2457,7 @@
           <a:lstStyle/>
           <a:p>
             <a:pPr algn="ctr"/>
-            <a:endParaRPr lang="en-US" sz="1800" dirty="0"/>
+            <a:endParaRPr lang="en-US" sz="1800"/>
           </a:p>
         </p:txBody>
       </p:sp>
@@ -2356,7 +2492,7 @@
           </a:lstStyle>
           <a:p>
             <a:r>
-              <a:rPr lang="en-US" dirty="0"/>
+              <a:rPr lang="en-US"/>
               <a:t>Copy goes here</a:t>
             </a:r>
           </a:p>
@@ -2489,7 +2625,7 @@
           <a:p>
             <a:pPr lvl="0"/>
             <a:r>
-              <a:rPr lang="en-US" dirty="0"/>
+              <a:rPr lang="en-US"/>
               <a:t>Supporting text goes here</a:t>
             </a:r>
           </a:p>
@@ -2520,7 +2656,7 @@
           <a:p>
             <a:fld id="{8923E60E-3077-9A4D-B784-FBCD6B1A2E3F}" type="datetimeFigureOut">
               <a:rPr lang="en-US" smtClean="0"/>
-              <a:t>1/22/2024</a:t>
+              <a:t>1/18/2026</a:t>
             </a:fld>
             <a:endParaRPr lang="en-US"/>
           </a:p>
@@ -2675,7 +2811,7 @@
           </a:lstStyle>
           <a:p>
             <a:r>
-              <a:rPr lang="en-US" dirty="0"/>
+              <a:rPr lang="en-US"/>
               <a:t>Click to edit Master title style</a:t>
             </a:r>
           </a:p>
@@ -2757,7 +2893,7 @@
           <a:p>
             <a:fld id="{8923E60E-3077-9A4D-B784-FBCD6B1A2E3F}" type="datetimeFigureOut">
               <a:rPr lang="en-US" smtClean="0"/>
-              <a:t>1/22/2024</a:t>
+              <a:t>1/18/2026</a:t>
             </a:fld>
             <a:endParaRPr lang="en-US"/>
           </a:p>
@@ -2860,7 +2996,7 @@
           <a:lstStyle/>
           <a:p>
             <a:pPr algn="ctr"/>
-            <a:endParaRPr lang="en-US" sz="1800" dirty="0"/>
+            <a:endParaRPr lang="en-US" sz="1800"/>
           </a:p>
         </p:txBody>
       </p:sp>
@@ -2894,7 +3030,7 @@
           <a:p>
             <a:pPr algn="r"/>
             <a:r>
-              <a:rPr lang="en-US" sz="1800" b="1" i="0" dirty="0">
+              <a:rPr lang="en-US" sz="1800" b="1" i="0">
                 <a:solidFill>
                   <a:schemeClr val="bg1"/>
                 </a:solidFill>
@@ -2905,7 +3041,7 @@
               <a:t>MINES</a:t>
             </a:r>
             <a:r>
-              <a:rPr lang="en-US" sz="1800" b="1" i="0" dirty="0">
+              <a:rPr lang="en-US" sz="1800" b="1" i="0">
                 <a:solidFill>
                   <a:srgbClr val="D2492A"/>
                 </a:solidFill>
@@ -2916,7 +3052,7 @@
               <a:t>.</a:t>
             </a:r>
             <a:r>
-              <a:rPr lang="en-US" sz="1800" b="0" i="0" dirty="0">
+              <a:rPr lang="en-US" sz="1800" b="0" i="0">
                 <a:solidFill>
                   <a:srgbClr val="92A2BD"/>
                 </a:solidFill>
@@ -3025,7 +3161,7 @@
           </a:lstStyle>
           <a:p>
             <a:r>
-              <a:rPr lang="en-US" dirty="0"/>
+              <a:rPr lang="en-US"/>
               <a:t>Click to edit Master title style</a:t>
             </a:r>
           </a:p>
@@ -3112,7 +3248,7 @@
           <a:p>
             <a:fld id="{8923E60E-3077-9A4D-B784-FBCD6B1A2E3F}" type="datetimeFigureOut">
               <a:rPr lang="en-US" smtClean="0"/>
-              <a:t>1/22/2024</a:t>
+              <a:t>1/18/2026</a:t>
             </a:fld>
             <a:endParaRPr lang="en-US"/>
           </a:p>
@@ -3215,7 +3351,7 @@
           <a:lstStyle/>
           <a:p>
             <a:pPr algn="ctr"/>
-            <a:endParaRPr lang="en-US" sz="1800" dirty="0"/>
+            <a:endParaRPr lang="en-US" sz="1800"/>
           </a:p>
         </p:txBody>
       </p:sp>
@@ -3249,7 +3385,7 @@
           <a:p>
             <a:pPr algn="r"/>
             <a:r>
-              <a:rPr lang="en-US" sz="1800" b="1" i="0" dirty="0">
+              <a:rPr lang="en-US" sz="1800" b="1" i="0">
                 <a:solidFill>
                   <a:schemeClr val="bg1"/>
                 </a:solidFill>
@@ -3260,7 +3396,7 @@
               <a:t>MINES</a:t>
             </a:r>
             <a:r>
-              <a:rPr lang="en-US" sz="1800" b="1" i="0" dirty="0">
+              <a:rPr lang="en-US" sz="1800" b="1" i="0">
                 <a:solidFill>
                   <a:srgbClr val="D2492A"/>
                 </a:solidFill>
@@ -3271,7 +3407,7 @@
               <a:t>.</a:t>
             </a:r>
             <a:r>
-              <a:rPr lang="en-US" sz="1800" b="0" i="0" dirty="0">
+              <a:rPr lang="en-US" sz="1800" b="0" i="0">
                 <a:solidFill>
                   <a:srgbClr val="92A2BD"/>
                 </a:solidFill>
@@ -3390,7 +3526,7 @@
           <a:lstStyle/>
           <a:p>
             <a:pPr algn="ctr"/>
-            <a:endParaRPr lang="en-US" sz="1800" dirty="0"/>
+            <a:endParaRPr lang="en-US" sz="1800"/>
           </a:p>
         </p:txBody>
       </p:sp>
@@ -3428,7 +3564,7 @@
           </a:lstStyle>
           <a:p>
             <a:r>
-              <a:rPr lang="en-US" dirty="0"/>
+              <a:rPr lang="en-US"/>
               <a:t>Section header goes here</a:t>
             </a:r>
           </a:p>
@@ -3548,7 +3684,7 @@
           <a:p>
             <a:pPr lvl="0"/>
             <a:r>
-              <a:rPr lang="en-US" dirty="0"/>
+              <a:rPr lang="en-US"/>
               <a:t>Section subhead goes here</a:t>
             </a:r>
           </a:p>
@@ -3579,7 +3715,7 @@
           <a:p>
             <a:fld id="{8923E60E-3077-9A4D-B784-FBCD6B1A2E3F}" type="datetimeFigureOut">
               <a:rPr lang="en-US" smtClean="0"/>
-              <a:t>1/22/2024</a:t>
+              <a:t>1/18/2026</a:t>
             </a:fld>
             <a:endParaRPr lang="en-US"/>
           </a:p>
@@ -3710,7 +3846,7 @@
           <a:p>
             <a:pPr algn="r"/>
             <a:r>
-              <a:rPr lang="en-US" sz="1800" b="1" i="0" dirty="0">
+              <a:rPr lang="en-US" sz="1800" b="1" i="0">
                 <a:solidFill>
                   <a:srgbClr val="21314D"/>
                 </a:solidFill>
@@ -3721,7 +3857,7 @@
               <a:t>MINES</a:t>
             </a:r>
             <a:r>
-              <a:rPr lang="en-US" sz="1800" b="1" i="0" dirty="0">
+              <a:rPr lang="en-US" sz="1800" b="1" i="0">
                 <a:solidFill>
                   <a:srgbClr val="D2492A"/>
                 </a:solidFill>
@@ -3732,7 +3868,7 @@
               <a:t>.</a:t>
             </a:r>
             <a:r>
-              <a:rPr lang="en-US" sz="1800" b="0" i="0" dirty="0">
+              <a:rPr lang="en-US" sz="1800" b="0" i="0">
                 <a:solidFill>
                   <a:srgbClr val="92A2BD"/>
                 </a:solidFill>
@@ -3799,7 +3935,7 @@
           </a:lstStyle>
           <a:p>
             <a:r>
-              <a:rPr lang="en-US" dirty="0"/>
+              <a:rPr lang="en-US"/>
               <a:t>Click to edit Master title style</a:t>
             </a:r>
           </a:p>
@@ -3844,7 +3980,7 @@
           <a:lstStyle/>
           <a:p>
             <a:pPr algn="ctr"/>
-            <a:endParaRPr lang="en-US" sz="1800" dirty="0"/>
+            <a:endParaRPr lang="en-US" sz="1800"/>
           </a:p>
         </p:txBody>
       </p:sp>
@@ -3865,35 +4001,35 @@
           <a:p>
             <a:pPr lvl="0"/>
             <a:r>
-              <a:rPr lang="en-US" dirty="0"/>
+              <a:rPr lang="en-US"/>
               <a:t>Click to edit Master text styles</a:t>
             </a:r>
           </a:p>
           <a:p>
             <a:pPr lvl="1"/>
             <a:r>
-              <a:rPr lang="en-US" dirty="0"/>
+              <a:rPr lang="en-US"/>
               <a:t>Second level</a:t>
             </a:r>
           </a:p>
           <a:p>
             <a:pPr lvl="2"/>
             <a:r>
-              <a:rPr lang="en-US" dirty="0"/>
+              <a:rPr lang="en-US"/>
               <a:t>Third level</a:t>
             </a:r>
           </a:p>
           <a:p>
             <a:pPr lvl="3"/>
             <a:r>
-              <a:rPr lang="en-US" dirty="0"/>
+              <a:rPr lang="en-US"/>
               <a:t>Fourth level</a:t>
             </a:r>
           </a:p>
           <a:p>
             <a:pPr lvl="4"/>
             <a:r>
-              <a:rPr lang="en-US" dirty="0"/>
+              <a:rPr lang="en-US"/>
               <a:t>Fifth level</a:t>
             </a:r>
           </a:p>
@@ -3924,7 +4060,7 @@
           <a:p>
             <a:fld id="{8923E60E-3077-9A4D-B784-FBCD6B1A2E3F}" type="datetimeFigureOut">
               <a:rPr lang="en-US" smtClean="0"/>
-              <a:t>1/22/2024</a:t>
+              <a:t>1/18/2026</a:t>
             </a:fld>
             <a:endParaRPr lang="en-US"/>
           </a:p>
@@ -4012,7 +4148,7 @@
           <a:p>
             <a:pPr algn="r"/>
             <a:r>
-              <a:rPr lang="en-US" sz="1800" b="1" i="0" dirty="0">
+              <a:rPr lang="en-US" sz="1800" b="1" i="0">
                 <a:solidFill>
                   <a:schemeClr val="bg1"/>
                 </a:solidFill>
@@ -4023,7 +4159,7 @@
               <a:t>MINES</a:t>
             </a:r>
             <a:r>
-              <a:rPr lang="en-US" sz="1800" b="1" i="0" dirty="0">
+              <a:rPr lang="en-US" sz="1800" b="1" i="0">
                 <a:solidFill>
                   <a:srgbClr val="D2492A"/>
                 </a:solidFill>
@@ -4034,7 +4170,7 @@
               <a:t>.</a:t>
             </a:r>
             <a:r>
-              <a:rPr lang="en-US" sz="1800" b="0" i="0" dirty="0">
+              <a:rPr lang="en-US" sz="1800" b="0" i="0">
                 <a:solidFill>
                   <a:srgbClr val="92A2BD"/>
                 </a:solidFill>
@@ -4138,7 +4274,7 @@
           </a:lstStyle>
           <a:p>
             <a:r>
-              <a:rPr lang="en-US" dirty="0"/>
+              <a:rPr lang="en-US"/>
               <a:t>Click to edit Master title style</a:t>
             </a:r>
           </a:p>
@@ -4166,35 +4302,35 @@
           <a:p>
             <a:pPr lvl="0"/>
             <a:r>
-              <a:rPr lang="en-US" dirty="0"/>
+              <a:rPr lang="en-US"/>
               <a:t>Click to edit Master text styles</a:t>
             </a:r>
           </a:p>
           <a:p>
             <a:pPr lvl="1"/>
             <a:r>
-              <a:rPr lang="en-US" dirty="0"/>
+              <a:rPr lang="en-US"/>
               <a:t>Second level</a:t>
             </a:r>
           </a:p>
           <a:p>
             <a:pPr lvl="2"/>
             <a:r>
-              <a:rPr lang="en-US" dirty="0"/>
+              <a:rPr lang="en-US"/>
               <a:t>Third level</a:t>
             </a:r>
           </a:p>
           <a:p>
             <a:pPr lvl="3"/>
             <a:r>
-              <a:rPr lang="en-US" dirty="0"/>
+              <a:rPr lang="en-US"/>
               <a:t>Fourth level</a:t>
             </a:r>
           </a:p>
           <a:p>
             <a:pPr lvl="4"/>
             <a:r>
-              <a:rPr lang="en-US" dirty="0"/>
+              <a:rPr lang="en-US"/>
               <a:t>Fifth level</a:t>
             </a:r>
           </a:p>
@@ -4222,35 +4358,35 @@
           <a:p>
             <a:pPr lvl="0"/>
             <a:r>
-              <a:rPr lang="en-US" dirty="0"/>
+              <a:rPr lang="en-US"/>
               <a:t>Click to edit Master text styles</a:t>
             </a:r>
           </a:p>
           <a:p>
             <a:pPr lvl="1"/>
             <a:r>
-              <a:rPr lang="en-US" dirty="0"/>
+              <a:rPr lang="en-US"/>
               <a:t>Second level</a:t>
             </a:r>
           </a:p>
           <a:p>
             <a:pPr lvl="2"/>
             <a:r>
-              <a:rPr lang="en-US" dirty="0"/>
+              <a:rPr lang="en-US"/>
               <a:t>Third level</a:t>
             </a:r>
           </a:p>
           <a:p>
             <a:pPr lvl="3"/>
             <a:r>
-              <a:rPr lang="en-US" dirty="0"/>
+              <a:rPr lang="en-US"/>
               <a:t>Fourth level</a:t>
             </a:r>
           </a:p>
           <a:p>
             <a:pPr lvl="4"/>
             <a:r>
-              <a:rPr lang="en-US" dirty="0"/>
+              <a:rPr lang="en-US"/>
               <a:t>Fifth level</a:t>
             </a:r>
           </a:p>
@@ -4281,7 +4417,7 @@
           <a:p>
             <a:fld id="{8923E60E-3077-9A4D-B784-FBCD6B1A2E3F}" type="datetimeFigureOut">
               <a:rPr lang="en-US" smtClean="0"/>
-              <a:t>1/22/2024</a:t>
+              <a:t>1/18/2026</a:t>
             </a:fld>
             <a:endParaRPr lang="en-US"/>
           </a:p>
@@ -4384,7 +4520,7 @@
           <a:lstStyle/>
           <a:p>
             <a:pPr algn="ctr"/>
-            <a:endParaRPr lang="en-US" sz="1800" dirty="0"/>
+            <a:endParaRPr lang="en-US" sz="1800"/>
           </a:p>
         </p:txBody>
       </p:sp>
@@ -4418,7 +4554,7 @@
           <a:p>
             <a:pPr algn="r"/>
             <a:r>
-              <a:rPr lang="en-US" sz="1800" b="1" i="0" dirty="0">
+              <a:rPr lang="en-US" sz="1800" b="1" i="0">
                 <a:solidFill>
                   <a:schemeClr val="bg1"/>
                 </a:solidFill>
@@ -4429,7 +4565,7 @@
               <a:t>MINES</a:t>
             </a:r>
             <a:r>
-              <a:rPr lang="en-US" sz="1800" b="1" i="0" dirty="0">
+              <a:rPr lang="en-US" sz="1800" b="1" i="0">
                 <a:solidFill>
                   <a:srgbClr val="D2492A"/>
                 </a:solidFill>
@@ -4440,7 +4576,7 @@
               <a:t>.</a:t>
             </a:r>
             <a:r>
-              <a:rPr lang="en-US" sz="1800" b="0" i="0" dirty="0">
+              <a:rPr lang="en-US" sz="1800" b="0" i="0">
                 <a:solidFill>
                   <a:srgbClr val="92A2BD"/>
                 </a:solidFill>
@@ -4549,7 +4685,7 @@
           </a:lstStyle>
           <a:p>
             <a:r>
-              <a:rPr lang="en-US" dirty="0"/>
+              <a:rPr lang="en-US"/>
               <a:t>Click to edit Master title style</a:t>
             </a:r>
           </a:p>
@@ -4614,7 +4750,7 @@
           <a:p>
             <a:pPr lvl="0"/>
             <a:r>
-              <a:rPr lang="en-US" dirty="0"/>
+              <a:rPr lang="en-US"/>
               <a:t>Click to edit Master text styles</a:t>
             </a:r>
           </a:p>
@@ -4822,7 +4958,7 @@
           <a:p>
             <a:fld id="{8923E60E-3077-9A4D-B784-FBCD6B1A2E3F}" type="datetimeFigureOut">
               <a:rPr lang="en-US" smtClean="0"/>
-              <a:t>1/22/2024</a:t>
+              <a:t>1/18/2026</a:t>
             </a:fld>
             <a:endParaRPr lang="en-US"/>
           </a:p>
@@ -4925,7 +5061,7 @@
           <a:lstStyle/>
           <a:p>
             <a:pPr algn="ctr"/>
-            <a:endParaRPr lang="en-US" sz="1800" dirty="0"/>
+            <a:endParaRPr lang="en-US" sz="1800"/>
           </a:p>
         </p:txBody>
       </p:sp>
@@ -4959,7 +5095,7 @@
           <a:p>
             <a:pPr algn="r"/>
             <a:r>
-              <a:rPr lang="en-US" sz="1800" b="1" i="0" dirty="0">
+              <a:rPr lang="en-US" sz="1800" b="1" i="0">
                 <a:solidFill>
                   <a:schemeClr val="bg1"/>
                 </a:solidFill>
@@ -4970,7 +5106,7 @@
               <a:t>MINES</a:t>
             </a:r>
             <a:r>
-              <a:rPr lang="en-US" sz="1800" b="1" i="0" dirty="0">
+              <a:rPr lang="en-US" sz="1800" b="1" i="0">
                 <a:solidFill>
                   <a:srgbClr val="D2492A"/>
                 </a:solidFill>
@@ -4981,7 +5117,7 @@
               <a:t>.</a:t>
             </a:r>
             <a:r>
-              <a:rPr lang="en-US" sz="1800" b="0" i="0" dirty="0">
+              <a:rPr lang="en-US" sz="1800" b="0" i="0">
                 <a:solidFill>
                   <a:srgbClr val="92A2BD"/>
                 </a:solidFill>
@@ -5085,7 +5221,7 @@
           </a:lstStyle>
           <a:p>
             <a:r>
-              <a:rPr lang="en-US" dirty="0"/>
+              <a:rPr lang="en-US"/>
               <a:t>Click to edit Master title style</a:t>
             </a:r>
           </a:p>
@@ -5116,7 +5252,7 @@
           <a:p>
             <a:fld id="{8923E60E-3077-9A4D-B784-FBCD6B1A2E3F}" type="datetimeFigureOut">
               <a:rPr lang="en-US" smtClean="0"/>
-              <a:t>1/22/2024</a:t>
+              <a:t>1/18/2026</a:t>
             </a:fld>
             <a:endParaRPr lang="en-US"/>
           </a:p>
@@ -5219,7 +5355,7 @@
           <a:lstStyle/>
           <a:p>
             <a:pPr algn="ctr"/>
-            <a:endParaRPr lang="en-US" sz="1800" dirty="0"/>
+            <a:endParaRPr lang="en-US" sz="1800"/>
           </a:p>
         </p:txBody>
       </p:sp>
@@ -5253,7 +5389,7 @@
           <a:p>
             <a:pPr algn="r"/>
             <a:r>
-              <a:rPr lang="en-US" sz="1800" b="1" i="0" dirty="0">
+              <a:rPr lang="en-US" sz="1800" b="1" i="0">
                 <a:solidFill>
                   <a:schemeClr val="bg1"/>
                 </a:solidFill>
@@ -5264,7 +5400,7 @@
               <a:t>MINES</a:t>
             </a:r>
             <a:r>
-              <a:rPr lang="en-US" sz="1800" b="1" i="0" dirty="0">
+              <a:rPr lang="en-US" sz="1800" b="1" i="0">
                 <a:solidFill>
                   <a:srgbClr val="D2492A"/>
                 </a:solidFill>
@@ -5275,7 +5411,7 @@
               <a:t>.</a:t>
             </a:r>
             <a:r>
-              <a:rPr lang="en-US" sz="1800" b="0" i="0" dirty="0">
+              <a:rPr lang="en-US" sz="1800" b="0" i="0">
                 <a:solidFill>
                   <a:srgbClr val="92A2BD"/>
                 </a:solidFill>
@@ -5380,7 +5516,7 @@
           <a:p>
             <a:fld id="{8923E60E-3077-9A4D-B784-FBCD6B1A2E3F}" type="datetimeFigureOut">
               <a:rPr lang="en-US" smtClean="0"/>
-              <a:t>1/22/2024</a:t>
+              <a:t>1/18/2026</a:t>
             </a:fld>
             <a:endParaRPr lang="en-US"/>
           </a:p>
@@ -5486,7 +5622,7 @@
           </a:lstStyle>
           <a:p>
             <a:r>
-              <a:rPr lang="en-US" sz="4400" b="1" i="0" dirty="0">
+              <a:rPr lang="en-US" sz="4400" b="1" i="0">
                 <a:latin typeface="Arial" panose="020B0604020202020204" pitchFamily="34" charset="0"/>
                 <a:cs typeface="Arial" panose="020B0604020202020204" pitchFamily="34" charset="0"/>
               </a:rPr>
@@ -5625,7 +5761,7 @@
           <a:lstStyle/>
           <a:p>
             <a:pPr algn="ctr"/>
-            <a:endParaRPr lang="en-US" sz="1800" dirty="0"/>
+            <a:endParaRPr lang="en-US" sz="1800"/>
           </a:p>
         </p:txBody>
       </p:sp>
@@ -5696,7 +5832,7 @@
           <a:p>
             <a:pPr algn="l"/>
             <a:r>
-              <a:rPr lang="en-US" dirty="0">
+              <a:rPr lang="en-US">
                 <a:solidFill>
                   <a:schemeClr val="bg1"/>
                 </a:solidFill>
@@ -5757,7 +5893,7 @@
           <a:lstStyle/>
           <a:p>
             <a:r>
-              <a:rPr lang="en-US" dirty="0"/>
+              <a:rPr lang="en-US"/>
               <a:t>Headline Copy Goes Here</a:t>
             </a:r>
           </a:p>
@@ -5784,13 +5920,13 @@
           <a:lstStyle/>
           <a:p>
             <a:r>
-              <a:rPr lang="en-US" dirty="0"/>
+              <a:rPr lang="en-US"/>
               <a:t>Click to add text</a:t>
             </a:r>
           </a:p>
           <a:p>
             <a:r>
-              <a:rPr lang="en-US" dirty="0"/>
+              <a:rPr lang="en-US"/>
               <a:t>Click to add text</a:t>
             </a:r>
           </a:p>
@@ -5881,7 +6017,7 @@
           <a:p>
             <a:pPr algn="r"/>
             <a:r>
-              <a:rPr lang="en-US" sz="1800" b="1" i="0" dirty="0">
+              <a:rPr lang="en-US" sz="1800" b="1" i="0">
                 <a:solidFill>
                   <a:srgbClr val="21314D"/>
                 </a:solidFill>
@@ -5892,7 +6028,7 @@
               <a:t>MINES</a:t>
             </a:r>
             <a:r>
-              <a:rPr lang="en-US" sz="1800" b="1" i="0" dirty="0">
+              <a:rPr lang="en-US" sz="1800" b="1" i="0">
                 <a:solidFill>
                   <a:srgbClr val="D2492A"/>
                 </a:solidFill>
@@ -5903,7 +6039,7 @@
               <a:t>.</a:t>
             </a:r>
             <a:r>
-              <a:rPr lang="en-US" sz="1800" b="0" i="0" dirty="0">
+              <a:rPr lang="en-US" sz="1800" b="0" i="0">
                 <a:solidFill>
                   <a:srgbClr val="92A2BD"/>
                 </a:solidFill>
@@ -5980,7 +6116,7 @@
           <a:lstStyle/>
           <a:p>
             <a:r>
-              <a:rPr lang="en-US" dirty="0"/>
+              <a:rPr lang="en-US"/>
               <a:t>Click to edit Master title style</a:t>
             </a:r>
           </a:p>
@@ -6013,35 +6149,35 @@
           <a:p>
             <a:pPr lvl="0"/>
             <a:r>
-              <a:rPr lang="en-US" dirty="0"/>
+              <a:rPr lang="en-US"/>
               <a:t>Click to edit Master text styles</a:t>
             </a:r>
           </a:p>
           <a:p>
             <a:pPr lvl="1"/>
             <a:r>
-              <a:rPr lang="en-US" dirty="0"/>
+              <a:rPr lang="en-US"/>
               <a:t>Second level</a:t>
             </a:r>
           </a:p>
           <a:p>
             <a:pPr lvl="2"/>
             <a:r>
-              <a:rPr lang="en-US" dirty="0"/>
+              <a:rPr lang="en-US"/>
               <a:t>Third level</a:t>
             </a:r>
           </a:p>
           <a:p>
             <a:pPr lvl="3"/>
             <a:r>
-              <a:rPr lang="en-US" dirty="0"/>
+              <a:rPr lang="en-US"/>
               <a:t>Fourth level</a:t>
             </a:r>
           </a:p>
           <a:p>
             <a:pPr lvl="4"/>
             <a:r>
-              <a:rPr lang="en-US" dirty="0"/>
+              <a:rPr lang="en-US"/>
               <a:t>Fifth level</a:t>
             </a:r>
           </a:p>
@@ -6393,15 +6529,15 @@
           <a:lstStyle/>
           <a:p>
             <a:r>
-              <a:rPr lang="en-US" dirty="0"/>
+              <a:rPr lang="en-US"/>
               <a:t>EENG 284</a:t>
             </a:r>
             <a:br>
-              <a:rPr lang="en-US" dirty="0"/>
+              <a:rPr lang="en-US"/>
             </a:br>
             <a:r>
-              <a:rPr lang="en-US" dirty="0"/>
-              <a:t>Introduction</a:t>
+              <a:rPr lang="en-US"/>
+              <a:t>Introduction To Quartus and Verilog</a:t>
             </a:r>
           </a:p>
         </p:txBody>
@@ -6410,6 +6546,1039 @@
     <p:extLst>
       <p:ext uri="{BB962C8B-B14F-4D97-AF65-F5344CB8AC3E}">
         <p14:creationId xmlns:p14="http://schemas.microsoft.com/office/powerpoint/2010/main" val="2018888763"/>
+      </p:ext>
+    </p:extLst>
+  </p:cSld>
+  <p:clrMapOvr>
+    <a:masterClrMapping/>
+  </p:clrMapOvr>
+</p:sld>
+</file>
+
+<file path=ppt/slides/slide10.xml><?xml version="1.0" encoding="utf-8"?>
+<p:sld xmlns:a="http://schemas.openxmlformats.org/drawingml/2006/main" xmlns:r="http://schemas.openxmlformats.org/officeDocument/2006/relationships" xmlns:p="http://schemas.openxmlformats.org/presentationml/2006/main">
+  <p:cSld>
+    <p:spTree>
+      <p:nvGrpSpPr>
+        <p:cNvPr id="1" name=""/>
+        <p:cNvGrpSpPr/>
+        <p:nvPr/>
+      </p:nvGrpSpPr>
+      <p:grpSpPr>
+        <a:xfrm>
+          <a:off x="0" y="0"/>
+          <a:ext cx="0" cy="0"/>
+          <a:chOff x="0" y="0"/>
+          <a:chExt cx="0" cy="0"/>
+        </a:xfrm>
+      </p:grpSpPr>
+      <p:sp>
+        <p:nvSpPr>
+          <p:cNvPr id="2" name="Title 1">
+            <a:extLst>
+              <a:ext uri="{FF2B5EF4-FFF2-40B4-BE49-F238E27FC236}">
+                <a16:creationId xmlns:a16="http://schemas.microsoft.com/office/drawing/2014/main" id="{A7CF0FC4-9F92-7F91-3ACD-E9D81335A967}"/>
+              </a:ext>
+            </a:extLst>
+          </p:cNvPr>
+          <p:cNvSpPr>
+            <a:spLocks noGrp="1"/>
+          </p:cNvSpPr>
+          <p:nvPr>
+            <p:ph type="title"/>
+          </p:nvPr>
+        </p:nvSpPr>
+        <p:spPr/>
+        <p:txBody>
+          <a:bodyPr/>
+          <a:lstStyle/>
+          <a:p>
+            <a:r>
+              <a:rPr lang="en-US"/>
+              <a:t>Installing Quartus Prime lite 24.1</a:t>
+            </a:r>
+          </a:p>
+        </p:txBody>
+      </p:sp>
+      <p:sp>
+        <p:nvSpPr>
+          <p:cNvPr id="3" name="Content Placeholder 2">
+            <a:extLst>
+              <a:ext uri="{FF2B5EF4-FFF2-40B4-BE49-F238E27FC236}">
+                <a16:creationId xmlns:a16="http://schemas.microsoft.com/office/drawing/2014/main" id="{BF951A63-93D6-BDE2-00B9-CE75B3FCA0FD}"/>
+              </a:ext>
+            </a:extLst>
+          </p:cNvPr>
+          <p:cNvSpPr>
+            <a:spLocks noGrp="1"/>
+          </p:cNvSpPr>
+          <p:nvPr>
+            <p:ph idx="1"/>
+          </p:nvPr>
+        </p:nvSpPr>
+        <p:spPr/>
+        <p:txBody>
+          <a:bodyPr>
+            <a:normAutofit lnSpcReduction="10000"/>
+          </a:bodyPr>
+          <a:lstStyle/>
+          <a:p>
+            <a:r>
+              <a:rPr lang="en-US" dirty="0"/>
+              <a:t>Go to course canvas module: Labs</a:t>
+            </a:r>
+          </a:p>
+          <a:p>
+            <a:r>
+              <a:rPr lang="en-US" dirty="0"/>
+              <a:t>Find the pdf document ‘How To 1 - Installing Quartus’, complete all the steps.</a:t>
+            </a:r>
+          </a:p>
+          <a:p>
+            <a:r>
+              <a:rPr lang="en-US" dirty="0"/>
+              <a:t>Find the pdf document ‘How To 2 - Creating a Project’, complete all the steps.</a:t>
+            </a:r>
+          </a:p>
+          <a:p>
+            <a:r>
+              <a:rPr lang="en-US" dirty="0"/>
+              <a:t>Find the pdf document ‘How T 3 – Performing a Simulation’, complete all the steps.</a:t>
+            </a:r>
+          </a:p>
+          <a:p>
+            <a:r>
+              <a:rPr lang="en-US" dirty="0"/>
+              <a:t>If you see the expected timing diagram at the end of simulation, your set up is complete. You will now be able to complete simulation component of labs anytime!</a:t>
+            </a:r>
+          </a:p>
+          <a:p>
+            <a:endParaRPr lang="en-US" dirty="0"/>
+          </a:p>
+          <a:p>
+            <a:endParaRPr lang="en-US" dirty="0"/>
+          </a:p>
+        </p:txBody>
+      </p:sp>
+    </p:spTree>
+    <p:extLst>
+      <p:ext uri="{BB962C8B-B14F-4D97-AF65-F5344CB8AC3E}">
+        <p14:creationId xmlns:p14="http://schemas.microsoft.com/office/powerpoint/2010/main" val="628043449"/>
+      </p:ext>
+    </p:extLst>
+  </p:cSld>
+  <p:clrMapOvr>
+    <a:masterClrMapping/>
+  </p:clrMapOvr>
+</p:sld>
+</file>
+
+<file path=ppt/slides/slide11.xml><?xml version="1.0" encoding="utf-8"?>
+<p:sld xmlns:a="http://schemas.openxmlformats.org/drawingml/2006/main" xmlns:r="http://schemas.openxmlformats.org/officeDocument/2006/relationships" xmlns:p="http://schemas.openxmlformats.org/presentationml/2006/main">
+  <p:cSld>
+    <p:spTree>
+      <p:nvGrpSpPr>
+        <p:cNvPr id="1" name="">
+          <a:extLst>
+            <a:ext uri="{FF2B5EF4-FFF2-40B4-BE49-F238E27FC236}">
+              <a16:creationId xmlns:a16="http://schemas.microsoft.com/office/drawing/2014/main" id="{BE7130D2-46EA-EF78-ADD0-598C7298E15D}"/>
+            </a:ext>
+          </a:extLst>
+        </p:cNvPr>
+        <p:cNvGrpSpPr/>
+        <p:nvPr/>
+      </p:nvGrpSpPr>
+      <p:grpSpPr>
+        <a:xfrm>
+          <a:off x="0" y="0"/>
+          <a:ext cx="0" cy="0"/>
+          <a:chOff x="0" y="0"/>
+          <a:chExt cx="0" cy="0"/>
+        </a:xfrm>
+      </p:grpSpPr>
+      <p:sp>
+        <p:nvSpPr>
+          <p:cNvPr id="2" name="Title 1">
+            <a:extLst>
+              <a:ext uri="{FF2B5EF4-FFF2-40B4-BE49-F238E27FC236}">
+                <a16:creationId xmlns:a16="http://schemas.microsoft.com/office/drawing/2014/main" id="{48CDCD4A-128F-62B6-8946-4714ED749E13}"/>
+              </a:ext>
+            </a:extLst>
+          </p:cNvPr>
+          <p:cNvSpPr>
+            <a:spLocks noGrp="1"/>
+          </p:cNvSpPr>
+          <p:nvPr>
+            <p:ph type="title"/>
+          </p:nvPr>
+        </p:nvSpPr>
+        <p:spPr/>
+        <p:txBody>
+          <a:bodyPr/>
+          <a:lstStyle/>
+          <a:p>
+            <a:r>
+              <a:rPr lang="en-US"/>
+              <a:t>Installing Quartus Prime lite 24.1</a:t>
+            </a:r>
+          </a:p>
+        </p:txBody>
+      </p:sp>
+      <p:sp>
+        <p:nvSpPr>
+          <p:cNvPr id="3" name="Content Placeholder 2">
+            <a:extLst>
+              <a:ext uri="{FF2B5EF4-FFF2-40B4-BE49-F238E27FC236}">
+                <a16:creationId xmlns:a16="http://schemas.microsoft.com/office/drawing/2014/main" id="{09D97A16-CFA3-8C84-7A0B-67F6E0B42ED4}"/>
+              </a:ext>
+            </a:extLst>
+          </p:cNvPr>
+          <p:cNvSpPr>
+            <a:spLocks noGrp="1"/>
+          </p:cNvSpPr>
+          <p:nvPr>
+            <p:ph idx="1"/>
+          </p:nvPr>
+        </p:nvSpPr>
+        <p:spPr/>
+        <p:txBody>
+          <a:bodyPr>
+            <a:normAutofit/>
+          </a:bodyPr>
+          <a:lstStyle/>
+          <a:p>
+            <a:r>
+              <a:rPr lang="en-US" dirty="0"/>
+              <a:t>Please complete the installation before next week.</a:t>
+            </a:r>
+          </a:p>
+          <a:p>
+            <a:r>
+              <a:rPr lang="en-US" dirty="0"/>
+              <a:t>Quartus prime lite will not work on iOS; use a lab computer.</a:t>
+            </a:r>
+          </a:p>
+          <a:p>
+            <a:endParaRPr lang="en-US" dirty="0"/>
+          </a:p>
+          <a:p>
+            <a:endParaRPr lang="en-US" dirty="0"/>
+          </a:p>
+          <a:p>
+            <a:endParaRPr lang="en-US" dirty="0"/>
+          </a:p>
+          <a:p>
+            <a:endParaRPr lang="en-US" dirty="0"/>
+          </a:p>
+        </p:txBody>
+      </p:sp>
+    </p:spTree>
+    <p:extLst>
+      <p:ext uri="{BB962C8B-B14F-4D97-AF65-F5344CB8AC3E}">
+        <p14:creationId xmlns:p14="http://schemas.microsoft.com/office/powerpoint/2010/main" val="1013848955"/>
+      </p:ext>
+    </p:extLst>
+  </p:cSld>
+  <p:clrMapOvr>
+    <a:masterClrMapping/>
+  </p:clrMapOvr>
+</p:sld>
+</file>
+
+<file path=ppt/slides/slide12.xml><?xml version="1.0" encoding="utf-8"?>
+<p:sld xmlns:a="http://schemas.openxmlformats.org/drawingml/2006/main" xmlns:r="http://schemas.openxmlformats.org/officeDocument/2006/relationships" xmlns:p="http://schemas.openxmlformats.org/presentationml/2006/main">
+  <p:cSld>
+    <p:spTree>
+      <p:nvGrpSpPr>
+        <p:cNvPr id="1" name=""/>
+        <p:cNvGrpSpPr/>
+        <p:nvPr/>
+      </p:nvGrpSpPr>
+      <p:grpSpPr>
+        <a:xfrm>
+          <a:off x="0" y="0"/>
+          <a:ext cx="0" cy="0"/>
+          <a:chOff x="0" y="0"/>
+          <a:chExt cx="0" cy="0"/>
+        </a:xfrm>
+      </p:grpSpPr>
+      <p:pic>
+        <p:nvPicPr>
+          <p:cNvPr id="5" name="Picture 4">
+            <a:extLst>
+              <a:ext uri="{FF2B5EF4-FFF2-40B4-BE49-F238E27FC236}">
+                <a16:creationId xmlns:a16="http://schemas.microsoft.com/office/drawing/2014/main" id="{1E1BCEEB-853E-6BAD-DA3C-F0F4CCB02120}"/>
+              </a:ext>
+            </a:extLst>
+          </p:cNvPr>
+          <p:cNvPicPr>
+            <a:picLocks noChangeAspect="1"/>
+          </p:cNvPicPr>
+          <p:nvPr/>
+        </p:nvPicPr>
+        <p:blipFill>
+          <a:blip r:embed="rId2"/>
+          <a:stretch>
+            <a:fillRect/>
+          </a:stretch>
+        </p:blipFill>
+        <p:spPr>
+          <a:xfrm>
+            <a:off x="1827285" y="2808560"/>
+            <a:ext cx="7125317" cy="1958510"/>
+          </a:xfrm>
+          <a:prstGeom prst="rect">
+            <a:avLst/>
+          </a:prstGeom>
+        </p:spPr>
+      </p:pic>
+      <p:sp>
+        <p:nvSpPr>
+          <p:cNvPr id="2" name="Title 1">
+            <a:extLst>
+              <a:ext uri="{FF2B5EF4-FFF2-40B4-BE49-F238E27FC236}">
+                <a16:creationId xmlns:a16="http://schemas.microsoft.com/office/drawing/2014/main" id="{FD4C31C8-62C8-8BC7-5649-57ECF8DAB0CC}"/>
+              </a:ext>
+            </a:extLst>
+          </p:cNvPr>
+          <p:cNvSpPr>
+            <a:spLocks noGrp="1"/>
+          </p:cNvSpPr>
+          <p:nvPr>
+            <p:ph type="title"/>
+          </p:nvPr>
+        </p:nvSpPr>
+        <p:spPr/>
+        <p:txBody>
+          <a:bodyPr/>
+          <a:lstStyle/>
+          <a:p>
+            <a:r>
+              <a:rPr lang="en-US"/>
+              <a:t>Launching Quartus Prime lite 24.1</a:t>
+            </a:r>
+          </a:p>
+        </p:txBody>
+      </p:sp>
+      <p:sp>
+        <p:nvSpPr>
+          <p:cNvPr id="3" name="Content Placeholder 2">
+            <a:extLst>
+              <a:ext uri="{FF2B5EF4-FFF2-40B4-BE49-F238E27FC236}">
+                <a16:creationId xmlns:a16="http://schemas.microsoft.com/office/drawing/2014/main" id="{5A76F6BE-5A21-7F2B-D5BE-32AEF4D93E91}"/>
+              </a:ext>
+            </a:extLst>
+          </p:cNvPr>
+          <p:cNvSpPr>
+            <a:spLocks noGrp="1"/>
+          </p:cNvSpPr>
+          <p:nvPr>
+            <p:ph idx="1"/>
+          </p:nvPr>
+        </p:nvSpPr>
+        <p:spPr/>
+        <p:txBody>
+          <a:bodyPr/>
+          <a:lstStyle/>
+          <a:p>
+            <a:r>
+              <a:rPr lang="en-US"/>
+              <a:t>On Lab computers</a:t>
+            </a:r>
+          </a:p>
+          <a:p>
+            <a:pPr lvl="1"/>
+            <a:r>
+              <a:rPr lang="de-DE"/>
+              <a:t>C:\intelFPGA_lite\24.1std\quartus\bin64\quartus.exe</a:t>
+            </a:r>
+          </a:p>
+          <a:p>
+            <a:pPr lvl="1"/>
+            <a:endParaRPr lang="de-DE"/>
+          </a:p>
+          <a:p>
+            <a:pPr lvl="1"/>
+            <a:endParaRPr lang="de-DE"/>
+          </a:p>
+          <a:p>
+            <a:pPr lvl="1"/>
+            <a:endParaRPr lang="de-DE"/>
+          </a:p>
+          <a:p>
+            <a:pPr lvl="1"/>
+            <a:endParaRPr lang="de-DE"/>
+          </a:p>
+          <a:p>
+            <a:pPr lvl="1"/>
+            <a:endParaRPr lang="de-DE"/>
+          </a:p>
+          <a:p>
+            <a:pPr lvl="1"/>
+            <a:endParaRPr lang="de-DE"/>
+          </a:p>
+          <a:p>
+            <a:pPr lvl="1"/>
+            <a:r>
+              <a:rPr lang="de-DE"/>
+              <a:t>This should launch Quartus Prime lite 24.1. You can also navigate to </a:t>
+            </a:r>
+          </a:p>
+          <a:p>
+            <a:pPr marL="457189" lvl="1" indent="0">
+              <a:buNone/>
+            </a:pPr>
+            <a:r>
+              <a:rPr lang="de-DE"/>
+              <a:t>C:\intelFPGA_lite\24.1std\quartus\bin64 and double click to open the executable application quartus.</a:t>
+            </a:r>
+          </a:p>
+          <a:p>
+            <a:pPr lvl="1"/>
+            <a:endParaRPr lang="de-DE"/>
+          </a:p>
+          <a:p>
+            <a:pPr lvl="1"/>
+            <a:endParaRPr lang="en-US"/>
+          </a:p>
+        </p:txBody>
+      </p:sp>
+      <p:sp>
+        <p:nvSpPr>
+          <p:cNvPr id="8" name="Rectangle 7">
+            <a:extLst>
+              <a:ext uri="{FF2B5EF4-FFF2-40B4-BE49-F238E27FC236}">
+                <a16:creationId xmlns:a16="http://schemas.microsoft.com/office/drawing/2014/main" id="{4D8C7679-F8FB-3D9D-84B4-FEEAD39764CD}"/>
+              </a:ext>
+            </a:extLst>
+          </p:cNvPr>
+          <p:cNvSpPr/>
+          <p:nvPr/>
+        </p:nvSpPr>
+        <p:spPr>
+          <a:xfrm>
+            <a:off x="2245489" y="3923818"/>
+            <a:ext cx="5879939" cy="347240"/>
+          </a:xfrm>
+          <a:prstGeom prst="rect">
+            <a:avLst/>
+          </a:prstGeom>
+          <a:noFill/>
+          <a:ln w="28575">
+            <a:solidFill>
+              <a:srgbClr val="C00000"/>
+            </a:solidFill>
+          </a:ln>
+        </p:spPr>
+        <p:style>
+          <a:lnRef idx="2">
+            <a:schemeClr val="accent1">
+              <a:shade val="15000"/>
+            </a:schemeClr>
+          </a:lnRef>
+          <a:fillRef idx="1">
+            <a:schemeClr val="accent1"/>
+          </a:fillRef>
+          <a:effectRef idx="0">
+            <a:schemeClr val="accent1"/>
+          </a:effectRef>
+          <a:fontRef idx="minor">
+            <a:schemeClr val="lt1"/>
+          </a:fontRef>
+        </p:style>
+        <p:txBody>
+          <a:bodyPr rtlCol="0" anchor="ctr"/>
+          <a:lstStyle/>
+          <a:p>
+            <a:pPr algn="ctr"/>
+            <a:endParaRPr lang="en-US"/>
+          </a:p>
+        </p:txBody>
+      </p:sp>
+      <p:sp>
+        <p:nvSpPr>
+          <p:cNvPr id="9" name="Rectangle 8">
+            <a:extLst>
+              <a:ext uri="{FF2B5EF4-FFF2-40B4-BE49-F238E27FC236}">
+                <a16:creationId xmlns:a16="http://schemas.microsoft.com/office/drawing/2014/main" id="{24657778-9875-ECC7-BFF1-12C61DD4BB2D}"/>
+              </a:ext>
+            </a:extLst>
+          </p:cNvPr>
+          <p:cNvSpPr/>
+          <p:nvPr/>
+        </p:nvSpPr>
+        <p:spPr>
+          <a:xfrm>
+            <a:off x="1527858" y="2233267"/>
+            <a:ext cx="7292051" cy="549208"/>
+          </a:xfrm>
+          <a:prstGeom prst="rect">
+            <a:avLst/>
+          </a:prstGeom>
+          <a:noFill/>
+          <a:ln w="28575">
+            <a:solidFill>
+              <a:srgbClr val="C00000"/>
+            </a:solidFill>
+          </a:ln>
+        </p:spPr>
+        <p:style>
+          <a:lnRef idx="2">
+            <a:schemeClr val="accent1">
+              <a:shade val="15000"/>
+            </a:schemeClr>
+          </a:lnRef>
+          <a:fillRef idx="1">
+            <a:schemeClr val="accent1"/>
+          </a:fillRef>
+          <a:effectRef idx="0">
+            <a:schemeClr val="accent1"/>
+          </a:effectRef>
+          <a:fontRef idx="minor">
+            <a:schemeClr val="lt1"/>
+          </a:fontRef>
+        </p:style>
+        <p:txBody>
+          <a:bodyPr rtlCol="0" anchor="ctr"/>
+          <a:lstStyle/>
+          <a:p>
+            <a:pPr algn="ctr"/>
+            <a:endParaRPr lang="en-US"/>
+          </a:p>
+        </p:txBody>
+      </p:sp>
+    </p:spTree>
+    <p:extLst>
+      <p:ext uri="{BB962C8B-B14F-4D97-AF65-F5344CB8AC3E}">
+        <p14:creationId xmlns:p14="http://schemas.microsoft.com/office/powerpoint/2010/main" val="3467334355"/>
+      </p:ext>
+    </p:extLst>
+  </p:cSld>
+  <p:clrMapOvr>
+    <a:masterClrMapping/>
+  </p:clrMapOvr>
+</p:sld>
+</file>
+
+<file path=ppt/slides/slide13.xml><?xml version="1.0" encoding="utf-8"?>
+<p:sld xmlns:a="http://schemas.openxmlformats.org/drawingml/2006/main" xmlns:r="http://schemas.openxmlformats.org/officeDocument/2006/relationships" xmlns:p="http://schemas.openxmlformats.org/presentationml/2006/main">
+  <p:cSld>
+    <p:spTree>
+      <p:nvGrpSpPr>
+        <p:cNvPr id="1" name="">
+          <a:extLst>
+            <a:ext uri="{FF2B5EF4-FFF2-40B4-BE49-F238E27FC236}">
+              <a16:creationId xmlns:a16="http://schemas.microsoft.com/office/drawing/2014/main" id="{887E92DF-CDCE-3C1F-02EA-1CABBC8667B4}"/>
+            </a:ext>
+          </a:extLst>
+        </p:cNvPr>
+        <p:cNvGrpSpPr/>
+        <p:nvPr/>
+      </p:nvGrpSpPr>
+      <p:grpSpPr>
+        <a:xfrm>
+          <a:off x="0" y="0"/>
+          <a:ext cx="0" cy="0"/>
+          <a:chOff x="0" y="0"/>
+          <a:chExt cx="0" cy="0"/>
+        </a:xfrm>
+      </p:grpSpPr>
+      <p:sp>
+        <p:nvSpPr>
+          <p:cNvPr id="2" name="Title 1">
+            <a:extLst>
+              <a:ext uri="{FF2B5EF4-FFF2-40B4-BE49-F238E27FC236}">
+                <a16:creationId xmlns:a16="http://schemas.microsoft.com/office/drawing/2014/main" id="{464B58AF-64D0-7D69-EE93-0CC6C8467776}"/>
+              </a:ext>
+            </a:extLst>
+          </p:cNvPr>
+          <p:cNvSpPr>
+            <a:spLocks noGrp="1"/>
+          </p:cNvSpPr>
+          <p:nvPr>
+            <p:ph type="title"/>
+          </p:nvPr>
+        </p:nvSpPr>
+        <p:spPr/>
+        <p:txBody>
+          <a:bodyPr/>
+          <a:lstStyle/>
+          <a:p>
+            <a:r>
+              <a:rPr lang="en-US"/>
+              <a:t>Launching Quartus Prime lite 24.1</a:t>
+            </a:r>
+          </a:p>
+        </p:txBody>
+      </p:sp>
+      <p:pic>
+        <p:nvPicPr>
+          <p:cNvPr id="7" name="Picture 6">
+            <a:extLst>
+              <a:ext uri="{FF2B5EF4-FFF2-40B4-BE49-F238E27FC236}">
+                <a16:creationId xmlns:a16="http://schemas.microsoft.com/office/drawing/2014/main" id="{BD03DC15-DBA7-CAD3-2A7B-21DAC636CBE0}"/>
+              </a:ext>
+            </a:extLst>
+          </p:cNvPr>
+          <p:cNvPicPr>
+            <a:picLocks noChangeAspect="1"/>
+          </p:cNvPicPr>
+          <p:nvPr/>
+        </p:nvPicPr>
+        <p:blipFill>
+          <a:blip r:embed="rId3"/>
+          <a:srcRect l="1366" t="3944"/>
+          <a:stretch>
+            <a:fillRect/>
+          </a:stretch>
+        </p:blipFill>
+        <p:spPr>
+          <a:xfrm>
+            <a:off x="4062719" y="2916820"/>
+            <a:ext cx="6098652" cy="3055717"/>
+          </a:xfrm>
+          <a:prstGeom prst="rect">
+            <a:avLst/>
+          </a:prstGeom>
+        </p:spPr>
+      </p:pic>
+      <p:sp>
+        <p:nvSpPr>
+          <p:cNvPr id="3" name="Content Placeholder 2">
+            <a:extLst>
+              <a:ext uri="{FF2B5EF4-FFF2-40B4-BE49-F238E27FC236}">
+                <a16:creationId xmlns:a16="http://schemas.microsoft.com/office/drawing/2014/main" id="{EFCEE15E-5428-6ABA-4DBD-DF1F565B2524}"/>
+              </a:ext>
+            </a:extLst>
+          </p:cNvPr>
+          <p:cNvSpPr>
+            <a:spLocks noGrp="1"/>
+          </p:cNvSpPr>
+          <p:nvPr>
+            <p:ph idx="1"/>
+          </p:nvPr>
+        </p:nvSpPr>
+        <p:spPr>
+          <a:xfrm>
+            <a:off x="838200" y="1687515"/>
+            <a:ext cx="10515600" cy="4351338"/>
+          </a:xfrm>
+        </p:spPr>
+        <p:txBody>
+          <a:bodyPr/>
+          <a:lstStyle/>
+          <a:p>
+            <a:r>
+              <a:rPr lang="en-US"/>
+              <a:t>On Lab computers</a:t>
+            </a:r>
+            <a:endParaRPr lang="de-DE"/>
+          </a:p>
+          <a:p>
+            <a:pPr lvl="1"/>
+            <a:r>
+              <a:rPr lang="de-DE"/>
+              <a:t>You can also search for ‘Quartus Prime‘, and make sure you open version 24.1</a:t>
+            </a:r>
+          </a:p>
+          <a:p>
+            <a:pPr lvl="1"/>
+            <a:endParaRPr lang="de-DE"/>
+          </a:p>
+          <a:p>
+            <a:pPr lvl="1"/>
+            <a:endParaRPr lang="de-DE"/>
+          </a:p>
+          <a:p>
+            <a:pPr lvl="1"/>
+            <a:endParaRPr lang="en-US"/>
+          </a:p>
+        </p:txBody>
+      </p:sp>
+      <p:sp>
+        <p:nvSpPr>
+          <p:cNvPr id="4" name="Rectangle 3">
+            <a:extLst>
+              <a:ext uri="{FF2B5EF4-FFF2-40B4-BE49-F238E27FC236}">
+                <a16:creationId xmlns:a16="http://schemas.microsoft.com/office/drawing/2014/main" id="{A399BC29-EFD2-A888-A9AC-227F375B1E23}"/>
+              </a:ext>
+            </a:extLst>
+          </p:cNvPr>
+          <p:cNvSpPr/>
+          <p:nvPr/>
+        </p:nvSpPr>
+        <p:spPr>
+          <a:xfrm>
+            <a:off x="4363660" y="3094101"/>
+            <a:ext cx="1759352" cy="415922"/>
+          </a:xfrm>
+          <a:prstGeom prst="rect">
+            <a:avLst/>
+          </a:prstGeom>
+          <a:noFill/>
+          <a:ln w="28575">
+            <a:solidFill>
+              <a:srgbClr val="C00000"/>
+            </a:solidFill>
+          </a:ln>
+        </p:spPr>
+        <p:style>
+          <a:lnRef idx="2">
+            <a:schemeClr val="accent1">
+              <a:shade val="15000"/>
+            </a:schemeClr>
+          </a:lnRef>
+          <a:fillRef idx="1">
+            <a:schemeClr val="accent1"/>
+          </a:fillRef>
+          <a:effectRef idx="0">
+            <a:schemeClr val="accent1"/>
+          </a:effectRef>
+          <a:fontRef idx="minor">
+            <a:schemeClr val="lt1"/>
+          </a:fontRef>
+        </p:style>
+        <p:txBody>
+          <a:bodyPr rtlCol="0" anchor="ctr"/>
+          <a:lstStyle/>
+          <a:p>
+            <a:pPr algn="ctr"/>
+            <a:endParaRPr lang="en-US"/>
+          </a:p>
+        </p:txBody>
+      </p:sp>
+      <p:sp>
+        <p:nvSpPr>
+          <p:cNvPr id="6" name="Rectangle 5">
+            <a:extLst>
+              <a:ext uri="{FF2B5EF4-FFF2-40B4-BE49-F238E27FC236}">
+                <a16:creationId xmlns:a16="http://schemas.microsoft.com/office/drawing/2014/main" id="{C615DE94-B353-4EB9-1FB1-90E222398859}"/>
+              </a:ext>
+            </a:extLst>
+          </p:cNvPr>
+          <p:cNvSpPr/>
+          <p:nvPr/>
+        </p:nvSpPr>
+        <p:spPr>
+          <a:xfrm>
+            <a:off x="4190039" y="4236717"/>
+            <a:ext cx="2554147" cy="595694"/>
+          </a:xfrm>
+          <a:prstGeom prst="rect">
+            <a:avLst/>
+          </a:prstGeom>
+          <a:noFill/>
+          <a:ln w="28575">
+            <a:solidFill>
+              <a:srgbClr val="C00000"/>
+            </a:solidFill>
+          </a:ln>
+        </p:spPr>
+        <p:style>
+          <a:lnRef idx="2">
+            <a:schemeClr val="accent1">
+              <a:shade val="15000"/>
+            </a:schemeClr>
+          </a:lnRef>
+          <a:fillRef idx="1">
+            <a:schemeClr val="accent1"/>
+          </a:fillRef>
+          <a:effectRef idx="0">
+            <a:schemeClr val="accent1"/>
+          </a:effectRef>
+          <a:fontRef idx="minor">
+            <a:schemeClr val="lt1"/>
+          </a:fontRef>
+        </p:style>
+        <p:txBody>
+          <a:bodyPr rtlCol="0" anchor="ctr"/>
+          <a:lstStyle/>
+          <a:p>
+            <a:pPr algn="ctr"/>
+            <a:endParaRPr lang="en-US"/>
+          </a:p>
+        </p:txBody>
+      </p:sp>
+      <p:sp>
+        <p:nvSpPr>
+          <p:cNvPr id="8" name="Rectangle 7">
+            <a:extLst>
+              <a:ext uri="{FF2B5EF4-FFF2-40B4-BE49-F238E27FC236}">
+                <a16:creationId xmlns:a16="http://schemas.microsoft.com/office/drawing/2014/main" id="{213DCFD2-0E30-C85F-FE34-90D677AD44EE}"/>
+              </a:ext>
+            </a:extLst>
+          </p:cNvPr>
+          <p:cNvSpPr/>
+          <p:nvPr/>
+        </p:nvSpPr>
+        <p:spPr>
+          <a:xfrm>
+            <a:off x="4190039" y="5559105"/>
+            <a:ext cx="2554147" cy="446590"/>
+          </a:xfrm>
+          <a:prstGeom prst="rect">
+            <a:avLst/>
+          </a:prstGeom>
+          <a:noFill/>
+          <a:ln w="28575">
+            <a:solidFill>
+              <a:srgbClr val="C00000"/>
+            </a:solidFill>
+          </a:ln>
+        </p:spPr>
+        <p:style>
+          <a:lnRef idx="2">
+            <a:schemeClr val="accent1">
+              <a:shade val="15000"/>
+            </a:schemeClr>
+          </a:lnRef>
+          <a:fillRef idx="1">
+            <a:schemeClr val="accent1"/>
+          </a:fillRef>
+          <a:effectRef idx="0">
+            <a:schemeClr val="accent1"/>
+          </a:effectRef>
+          <a:fontRef idx="minor">
+            <a:schemeClr val="lt1"/>
+          </a:fontRef>
+        </p:style>
+        <p:txBody>
+          <a:bodyPr rtlCol="0" anchor="ctr"/>
+          <a:lstStyle/>
+          <a:p>
+            <a:pPr algn="ctr"/>
+            <a:endParaRPr lang="en-US"/>
+          </a:p>
+        </p:txBody>
+      </p:sp>
+      <p:sp>
+        <p:nvSpPr>
+          <p:cNvPr id="10" name="TextBox 9">
+            <a:extLst>
+              <a:ext uri="{FF2B5EF4-FFF2-40B4-BE49-F238E27FC236}">
+                <a16:creationId xmlns:a16="http://schemas.microsoft.com/office/drawing/2014/main" id="{3EBB98BE-858E-1CD9-760F-E674C02A9AA0}"/>
+              </a:ext>
+            </a:extLst>
+          </p:cNvPr>
+          <p:cNvSpPr txBox="1"/>
+          <p:nvPr/>
+        </p:nvSpPr>
+        <p:spPr>
+          <a:xfrm>
+            <a:off x="164215" y="3183038"/>
+            <a:ext cx="3551258" cy="923330"/>
+          </a:xfrm>
+          <a:prstGeom prst="rect">
+            <a:avLst/>
+          </a:prstGeom>
+          <a:noFill/>
+          <a:ln>
+            <a:solidFill>
+              <a:schemeClr val="tx1"/>
+            </a:solidFill>
+          </a:ln>
+        </p:spPr>
+        <p:txBody>
+          <a:bodyPr wrap="square" rtlCol="0">
+            <a:spAutoFit/>
+          </a:bodyPr>
+          <a:lstStyle/>
+          <a:p>
+            <a:r>
+              <a:rPr lang="en-US" dirty="0"/>
+              <a:t>If there are multiple version of Quartus on the computer, </a:t>
+            </a:r>
+            <a:r>
+              <a:rPr lang="en-US" b="1" dirty="0"/>
+              <a:t>open the latest version 24.1</a:t>
+            </a:r>
+          </a:p>
+        </p:txBody>
+      </p:sp>
+      <p:cxnSp>
+        <p:nvCxnSpPr>
+          <p:cNvPr id="12" name="Straight Arrow Connector 11">
+            <a:extLst>
+              <a:ext uri="{FF2B5EF4-FFF2-40B4-BE49-F238E27FC236}">
+                <a16:creationId xmlns:a16="http://schemas.microsoft.com/office/drawing/2014/main" id="{FB1E48A8-058B-04EB-DD0E-698E26C0A021}"/>
+              </a:ext>
+            </a:extLst>
+          </p:cNvPr>
+          <p:cNvCxnSpPr>
+            <a:stCxn id="10" idx="3"/>
+          </p:cNvCxnSpPr>
+          <p:nvPr/>
+        </p:nvCxnSpPr>
+        <p:spPr>
+          <a:xfrm flipV="1">
+            <a:off x="3715473" y="3298785"/>
+            <a:ext cx="648187" cy="345918"/>
+          </a:xfrm>
+          <a:prstGeom prst="straightConnector1">
+            <a:avLst/>
+          </a:prstGeom>
+          <a:ln w="19050">
+            <a:solidFill>
+              <a:srgbClr val="C00000"/>
+            </a:solidFill>
+            <a:tailEnd type="stealth" w="lg" len="lg"/>
+          </a:ln>
+        </p:spPr>
+        <p:style>
+          <a:lnRef idx="1">
+            <a:schemeClr val="accent1"/>
+          </a:lnRef>
+          <a:fillRef idx="0">
+            <a:schemeClr val="accent1"/>
+          </a:fillRef>
+          <a:effectRef idx="0">
+            <a:schemeClr val="accent1"/>
+          </a:effectRef>
+          <a:fontRef idx="minor">
+            <a:schemeClr val="tx1"/>
+          </a:fontRef>
+        </p:style>
+      </p:cxnSp>
+      <p:cxnSp>
+        <p:nvCxnSpPr>
+          <p:cNvPr id="14" name="Straight Arrow Connector 13">
+            <a:extLst>
+              <a:ext uri="{FF2B5EF4-FFF2-40B4-BE49-F238E27FC236}">
+                <a16:creationId xmlns:a16="http://schemas.microsoft.com/office/drawing/2014/main" id="{F734A400-933C-BBE1-FEC5-4CEEE928A6DB}"/>
+              </a:ext>
+            </a:extLst>
+          </p:cNvPr>
+          <p:cNvCxnSpPr>
+            <a:stCxn id="10" idx="3"/>
+            <a:endCxn id="6" idx="1"/>
+          </p:cNvCxnSpPr>
+          <p:nvPr/>
+        </p:nvCxnSpPr>
+        <p:spPr>
+          <a:xfrm>
+            <a:off x="3715473" y="3644703"/>
+            <a:ext cx="474566" cy="889861"/>
+          </a:xfrm>
+          <a:prstGeom prst="straightConnector1">
+            <a:avLst/>
+          </a:prstGeom>
+          <a:ln w="19050">
+            <a:solidFill>
+              <a:srgbClr val="C00000"/>
+            </a:solidFill>
+            <a:tailEnd type="stealth" w="lg" len="lg"/>
+          </a:ln>
+        </p:spPr>
+        <p:style>
+          <a:lnRef idx="1">
+            <a:schemeClr val="accent1"/>
+          </a:lnRef>
+          <a:fillRef idx="0">
+            <a:schemeClr val="accent1"/>
+          </a:fillRef>
+          <a:effectRef idx="0">
+            <a:schemeClr val="accent1"/>
+          </a:effectRef>
+          <a:fontRef idx="minor">
+            <a:schemeClr val="tx1"/>
+          </a:fontRef>
+        </p:style>
+      </p:cxnSp>
+      <p:sp>
+        <p:nvSpPr>
+          <p:cNvPr id="16" name="TextBox 15">
+            <a:extLst>
+              <a:ext uri="{FF2B5EF4-FFF2-40B4-BE49-F238E27FC236}">
+                <a16:creationId xmlns:a16="http://schemas.microsoft.com/office/drawing/2014/main" id="{BE2DFC9A-890D-F74B-C06A-05B2CF21CB44}"/>
+              </a:ext>
+            </a:extLst>
+          </p:cNvPr>
+          <p:cNvSpPr txBox="1"/>
+          <p:nvPr/>
+        </p:nvSpPr>
+        <p:spPr>
+          <a:xfrm>
+            <a:off x="174469" y="5264447"/>
+            <a:ext cx="3551258" cy="923330"/>
+          </a:xfrm>
+          <a:prstGeom prst="rect">
+            <a:avLst/>
+          </a:prstGeom>
+          <a:noFill/>
+          <a:ln>
+            <a:solidFill>
+              <a:schemeClr val="tx1"/>
+            </a:solidFill>
+          </a:ln>
+        </p:spPr>
+        <p:txBody>
+          <a:bodyPr wrap="square" rtlCol="0">
+            <a:spAutoFit/>
+          </a:bodyPr>
+          <a:lstStyle/>
+          <a:p>
+            <a:r>
+              <a:rPr lang="en-US" b="1"/>
+              <a:t>Do not launch the Programmer </a:t>
+            </a:r>
+            <a:r>
+              <a:rPr lang="en-US"/>
+              <a:t>which might show up as a top choice in your search result</a:t>
+            </a:r>
+            <a:endParaRPr lang="en-US" b="1"/>
+          </a:p>
+        </p:txBody>
+      </p:sp>
+      <p:cxnSp>
+        <p:nvCxnSpPr>
+          <p:cNvPr id="17" name="Straight Arrow Connector 16">
+            <a:extLst>
+              <a:ext uri="{FF2B5EF4-FFF2-40B4-BE49-F238E27FC236}">
+                <a16:creationId xmlns:a16="http://schemas.microsoft.com/office/drawing/2014/main" id="{ED7A92D8-773A-FCDA-7341-AE7E30DA9DBB}"/>
+              </a:ext>
+            </a:extLst>
+          </p:cNvPr>
+          <p:cNvCxnSpPr>
+            <a:cxnSpLocks/>
+            <a:stCxn id="16" idx="3"/>
+            <a:endCxn id="8" idx="1"/>
+          </p:cNvCxnSpPr>
+          <p:nvPr/>
+        </p:nvCxnSpPr>
+        <p:spPr>
+          <a:xfrm>
+            <a:off x="3725727" y="5726112"/>
+            <a:ext cx="464312" cy="56288"/>
+          </a:xfrm>
+          <a:prstGeom prst="straightConnector1">
+            <a:avLst/>
+          </a:prstGeom>
+          <a:ln w="19050">
+            <a:solidFill>
+              <a:srgbClr val="C00000"/>
+            </a:solidFill>
+            <a:tailEnd type="stealth" w="lg" len="lg"/>
+          </a:ln>
+        </p:spPr>
+        <p:style>
+          <a:lnRef idx="1">
+            <a:schemeClr val="accent1"/>
+          </a:lnRef>
+          <a:fillRef idx="0">
+            <a:schemeClr val="accent1"/>
+          </a:fillRef>
+          <a:effectRef idx="0">
+            <a:schemeClr val="accent1"/>
+          </a:effectRef>
+          <a:fontRef idx="minor">
+            <a:schemeClr val="tx1"/>
+          </a:fontRef>
+        </p:style>
+      </p:cxnSp>
+    </p:spTree>
+    <p:extLst>
+      <p:ext uri="{BB962C8B-B14F-4D97-AF65-F5344CB8AC3E}">
+        <p14:creationId xmlns:p14="http://schemas.microsoft.com/office/powerpoint/2010/main" val="3995809676"/>
       </p:ext>
     </p:extLst>
   </p:cSld>
@@ -6452,8 +7621,8 @@
           <a:lstStyle/>
           <a:p>
             <a:r>
-              <a:rPr lang="en-US" dirty="0"/>
-              <a:t>Who are we?</a:t>
+              <a:rPr lang="en-US"/>
+              <a:t>Lab Objectives</a:t>
             </a:r>
           </a:p>
         </p:txBody>
@@ -6476,322 +7645,87 @@
         </p:spPr>
         <p:txBody>
           <a:bodyPr>
-            <a:normAutofit/>
+            <a:normAutofit lnSpcReduction="10000"/>
           </a:bodyPr>
           <a:lstStyle/>
+          <a:p>
+            <a:r>
+              <a:rPr lang="en-US"/>
+              <a:t>Working with the </a:t>
+            </a:r>
+            <a:r>
+              <a:rPr lang="en-US" err="1"/>
+              <a:t>Quartus</a:t>
+            </a:r>
+            <a:r>
+              <a:rPr lang="en-US"/>
+              <a:t> IDE</a:t>
+            </a:r>
+          </a:p>
+          <a:p>
+            <a:r>
+              <a:rPr lang="en-US"/>
+              <a:t>Verilog skills</a:t>
+            </a:r>
+          </a:p>
+          <a:p>
+            <a:pPr lvl="1"/>
+            <a:r>
+              <a:rPr lang="en-US"/>
+              <a:t>Creating logical expressions in Verilog</a:t>
+            </a:r>
+          </a:p>
+          <a:p>
+            <a:pPr lvl="1"/>
+            <a:r>
+              <a:rPr lang="en-US"/>
+              <a:t>Concurrent Signal Assignments</a:t>
+            </a:r>
+          </a:p>
+          <a:p>
+            <a:r>
+              <a:rPr lang="en-US"/>
+              <a:t>Simulation</a:t>
+            </a:r>
+          </a:p>
+          <a:p>
+            <a:pPr lvl="1"/>
+            <a:r>
+              <a:rPr lang="en-US"/>
+              <a:t>Working with </a:t>
+            </a:r>
+            <a:r>
+              <a:rPr lang="en-US" err="1"/>
+              <a:t>testbenches</a:t>
+            </a:r>
+            <a:endParaRPr lang="en-US"/>
+          </a:p>
+          <a:p>
+            <a:pPr lvl="1"/>
+            <a:r>
+              <a:rPr lang="en-US"/>
+              <a:t>Working with Questa (run command)</a:t>
+            </a:r>
+          </a:p>
+          <a:p>
+            <a:pPr lvl="1"/>
+            <a:r>
+              <a:rPr lang="en-US"/>
+              <a:t>Creating timing diagrams</a:t>
+            </a:r>
+          </a:p>
+          <a:p>
+            <a:pPr lvl="1"/>
+            <a:r>
+              <a:rPr lang="en-US"/>
+              <a:t>Verifying design</a:t>
+            </a:r>
+          </a:p>
           <a:p>
             <a:pPr marL="0" indent="0">
               <a:buNone/>
             </a:pPr>
-            <a:r>
-              <a:rPr lang="en-US" sz="2800"/>
-              <a:t>Introduce yourself.</a:t>
-            </a:r>
-            <a:endParaRPr lang="en-US" sz="2800" dirty="0"/>
-          </a:p>
-        </p:txBody>
-      </p:sp>
-    </p:spTree>
-    <p:extLst>
-      <p:ext uri="{BB962C8B-B14F-4D97-AF65-F5344CB8AC3E}">
-        <p14:creationId xmlns:p14="http://schemas.microsoft.com/office/powerpoint/2010/main" val="2263269761"/>
-      </p:ext>
-    </p:extLst>
-  </p:cSld>
-  <p:clrMapOvr>
-    <a:masterClrMapping/>
-  </p:clrMapOvr>
-  <p:timing>
-    <p:tnLst>
-      <p:par>
-        <p:cTn id="1" dur="indefinite" restart="never" nodeType="tmRoot">
-          <p:childTnLst>
-            <p:seq concurrent="1" nextAc="seek">
-              <p:cTn id="2" dur="indefinite" nodeType="mainSeq">
-                <p:childTnLst>
-                  <p:par>
-                    <p:cTn id="3" fill="hold">
-                      <p:stCondLst>
-                        <p:cond delay="indefinite"/>
-                      </p:stCondLst>
-                      <p:childTnLst>
-                        <p:par>
-                          <p:cTn id="4" fill="hold">
-                            <p:stCondLst>
-                              <p:cond delay="0"/>
-                            </p:stCondLst>
-                            <p:childTnLst>
-                              <p:par>
-                                <p:cTn id="5" presetID="1" presetClass="entr" presetSubtype="0" fill="hold" grpId="0" nodeType="clickEffect">
-                                  <p:stCondLst>
-                                    <p:cond delay="0"/>
-                                  </p:stCondLst>
-                                  <p:childTnLst>
-                                    <p:set>
-                                      <p:cBhvr>
-                                        <p:cTn id="6" dur="1" fill="hold">
-                                          <p:stCondLst>
-                                            <p:cond delay="0"/>
-                                          </p:stCondLst>
-                                        </p:cTn>
-                                        <p:tgtEl>
-                                          <p:spTgt spid="3">
-                                            <p:txEl>
-                                              <p:pRg st="0" end="0"/>
-                                            </p:txEl>
-                                          </p:spTgt>
-                                        </p:tgtEl>
-                                        <p:attrNameLst>
-                                          <p:attrName>style.visibility</p:attrName>
-                                        </p:attrNameLst>
-                                      </p:cBhvr>
-                                      <p:to>
-                                        <p:strVal val="visible"/>
-                                      </p:to>
-                                    </p:set>
-                                  </p:childTnLst>
-                                </p:cTn>
-                              </p:par>
-                            </p:childTnLst>
-                          </p:cTn>
-                        </p:par>
-                      </p:childTnLst>
-                    </p:cTn>
-                  </p:par>
-                </p:childTnLst>
-              </p:cTn>
-              <p:prevCondLst>
-                <p:cond evt="onPrev" delay="0">
-                  <p:tgtEl>
-                    <p:sldTgt/>
-                  </p:tgtEl>
-                </p:cond>
-              </p:prevCondLst>
-              <p:nextCondLst>
-                <p:cond evt="onNext" delay="0">
-                  <p:tgtEl>
-                    <p:sldTgt/>
-                  </p:tgtEl>
-                </p:cond>
-              </p:nextCondLst>
-            </p:seq>
-          </p:childTnLst>
-        </p:cTn>
-      </p:par>
-    </p:tnLst>
-    <p:bldLst>
-      <p:bldP spid="3" grpId="0" build="p"/>
-    </p:bldLst>
-  </p:timing>
-</p:sld>
-</file>
-
-<file path=ppt/slides/slide3.xml><?xml version="1.0" encoding="utf-8"?>
-<p:sld xmlns:a="http://schemas.openxmlformats.org/drawingml/2006/main" xmlns:r="http://schemas.openxmlformats.org/officeDocument/2006/relationships" xmlns:p="http://schemas.openxmlformats.org/presentationml/2006/main">
-  <p:cSld>
-    <p:spTree>
-      <p:nvGrpSpPr>
-        <p:cNvPr id="1" name=""/>
-        <p:cNvGrpSpPr/>
-        <p:nvPr/>
-      </p:nvGrpSpPr>
-      <p:grpSpPr>
-        <a:xfrm>
-          <a:off x="0" y="0"/>
-          <a:ext cx="0" cy="0"/>
-          <a:chOff x="0" y="0"/>
-          <a:chExt cx="0" cy="0"/>
-        </a:xfrm>
-      </p:grpSpPr>
-      <p:pic>
-        <p:nvPicPr>
-          <p:cNvPr id="5" name="Picture 4">
-            <a:extLst>
-              <a:ext uri="{FF2B5EF4-FFF2-40B4-BE49-F238E27FC236}">
-                <a16:creationId xmlns:a16="http://schemas.microsoft.com/office/drawing/2014/main" id="{7FAC0A05-A0F7-4E0B-094B-C75777F01F81}"/>
-              </a:ext>
-            </a:extLst>
-          </p:cNvPr>
-          <p:cNvPicPr>
-            <a:picLocks noChangeAspect="1"/>
-          </p:cNvPicPr>
-          <p:nvPr/>
-        </p:nvPicPr>
-        <p:blipFill>
-          <a:blip r:embed="rId2"/>
-          <a:stretch>
-            <a:fillRect/>
-          </a:stretch>
-        </p:blipFill>
-        <p:spPr>
-          <a:xfrm>
-            <a:off x="1371603" y="53162"/>
-            <a:ext cx="9454201" cy="6163357"/>
-          </a:xfrm>
-          <a:prstGeom prst="rect">
-            <a:avLst/>
-          </a:prstGeom>
-        </p:spPr>
-      </p:pic>
-    </p:spTree>
-    <p:extLst>
-      <p:ext uri="{BB962C8B-B14F-4D97-AF65-F5344CB8AC3E}">
-        <p14:creationId xmlns:p14="http://schemas.microsoft.com/office/powerpoint/2010/main" val="1684649394"/>
-      </p:ext>
-    </p:extLst>
-  </p:cSld>
-  <p:clrMapOvr>
-    <a:masterClrMapping/>
-  </p:clrMapOvr>
-</p:sld>
-</file>
-
-<file path=ppt/slides/slide4.xml><?xml version="1.0" encoding="utf-8"?>
-<p:sld xmlns:a="http://schemas.openxmlformats.org/drawingml/2006/main" xmlns:r="http://schemas.openxmlformats.org/officeDocument/2006/relationships" xmlns:p="http://schemas.openxmlformats.org/presentationml/2006/main">
-  <p:cSld>
-    <p:spTree>
-      <p:nvGrpSpPr>
-        <p:cNvPr id="1" name=""/>
-        <p:cNvGrpSpPr/>
-        <p:nvPr/>
-      </p:nvGrpSpPr>
-      <p:grpSpPr>
-        <a:xfrm>
-          <a:off x="0" y="0"/>
-          <a:ext cx="0" cy="0"/>
-          <a:chOff x="0" y="0"/>
-          <a:chExt cx="0" cy="0"/>
-        </a:xfrm>
-      </p:grpSpPr>
-      <p:sp>
-        <p:nvSpPr>
-          <p:cNvPr id="2" name="Title 1"/>
-          <p:cNvSpPr>
-            <a:spLocks noGrp="1"/>
-          </p:cNvSpPr>
-          <p:nvPr>
-            <p:ph type="title"/>
-          </p:nvPr>
-        </p:nvSpPr>
-        <p:spPr/>
-        <p:txBody>
-          <a:bodyPr/>
-          <a:lstStyle/>
-          <a:p>
-            <a:r>
-              <a:rPr lang="en-US" dirty="0"/>
-              <a:t>Lab Objectives</a:t>
-            </a:r>
-          </a:p>
-        </p:txBody>
-      </p:sp>
-      <p:sp>
-        <p:nvSpPr>
-          <p:cNvPr id="3" name="Content Placeholder 2"/>
-          <p:cNvSpPr>
-            <a:spLocks noGrp="1"/>
-          </p:cNvSpPr>
-          <p:nvPr>
-            <p:ph idx="1"/>
-          </p:nvPr>
-        </p:nvSpPr>
-        <p:spPr>
-          <a:xfrm>
-            <a:off x="838200" y="1825625"/>
-            <a:ext cx="10515600" cy="3591201"/>
-          </a:xfrm>
-        </p:spPr>
-        <p:txBody>
-          <a:bodyPr>
-            <a:normAutofit lnSpcReduction="10000"/>
-          </a:bodyPr>
-          <a:lstStyle/>
-          <a:p>
-            <a:r>
-              <a:rPr lang="en-US" dirty="0"/>
-              <a:t>Working with the </a:t>
-            </a:r>
-            <a:r>
-              <a:rPr lang="en-US" dirty="0" err="1"/>
-              <a:t>Quartus</a:t>
-            </a:r>
-            <a:r>
-              <a:rPr lang="en-US" dirty="0"/>
-              <a:t> IDE</a:t>
-            </a:r>
-          </a:p>
-          <a:p>
-            <a:r>
-              <a:rPr lang="en-US" dirty="0"/>
-              <a:t>Verilog skills</a:t>
-            </a:r>
-          </a:p>
-          <a:p>
-            <a:pPr lvl="1"/>
-            <a:r>
-              <a:rPr lang="en-US" dirty="0"/>
-              <a:t>Creating logical expressions in Verilog</a:t>
-            </a:r>
-          </a:p>
-          <a:p>
-            <a:pPr lvl="1"/>
-            <a:r>
-              <a:rPr lang="en-US" dirty="0"/>
-              <a:t>Concurrent Signal Assignments</a:t>
-            </a:r>
-          </a:p>
-          <a:p>
-            <a:r>
-              <a:rPr lang="en-US" dirty="0"/>
-              <a:t>Simulation</a:t>
-            </a:r>
-          </a:p>
-          <a:p>
-            <a:pPr lvl="1"/>
-            <a:r>
-              <a:rPr lang="en-US" dirty="0"/>
-              <a:t>Working with </a:t>
-            </a:r>
-            <a:r>
-              <a:rPr lang="en-US" dirty="0" err="1"/>
-              <a:t>testbenches</a:t>
-            </a:r>
-            <a:endParaRPr lang="en-US" dirty="0"/>
-          </a:p>
-          <a:p>
-            <a:pPr lvl="1"/>
-            <a:r>
-              <a:rPr lang="en-US" dirty="0"/>
-              <a:t>Working with </a:t>
-            </a:r>
-            <a:r>
-              <a:rPr lang="en-US" dirty="0" err="1"/>
-              <a:t>ModelSim</a:t>
-            </a:r>
-            <a:r>
-              <a:rPr lang="en-US" dirty="0"/>
-              <a:t> (run command)</a:t>
-            </a:r>
-          </a:p>
-          <a:p>
-            <a:pPr lvl="1"/>
-            <a:r>
-              <a:rPr lang="en-US" dirty="0"/>
-              <a:t>Creating timing diagrams</a:t>
-            </a:r>
-          </a:p>
-          <a:p>
-            <a:pPr lvl="1"/>
-            <a:r>
-              <a:rPr lang="en-US" dirty="0"/>
-              <a:t>Verifying design</a:t>
-            </a:r>
-          </a:p>
-          <a:p>
-            <a:pPr marL="0" indent="0">
-              <a:buNone/>
-            </a:pPr>
-            <a:endParaRPr lang="en-US" sz="2800" dirty="0"/>
+            <a:endParaRPr lang="en-US" sz="2800"/>
           </a:p>
         </p:txBody>
       </p:sp>
@@ -7174,6 +8108,270 @@
 </p:sld>
 </file>
 
+<file path=ppt/slides/slide3.xml><?xml version="1.0" encoding="utf-8"?>
+<p:sld xmlns:a="http://schemas.openxmlformats.org/drawingml/2006/main" xmlns:r="http://schemas.openxmlformats.org/officeDocument/2006/relationships" xmlns:p="http://schemas.openxmlformats.org/presentationml/2006/main">
+  <p:cSld>
+    <p:spTree>
+      <p:nvGrpSpPr>
+        <p:cNvPr id="1" name="">
+          <a:extLst>
+            <a:ext uri="{FF2B5EF4-FFF2-40B4-BE49-F238E27FC236}">
+              <a16:creationId xmlns:a16="http://schemas.microsoft.com/office/drawing/2014/main" id="{F299A3C8-516E-F126-8C0D-C856D6680840}"/>
+            </a:ext>
+          </a:extLst>
+        </p:cNvPr>
+        <p:cNvGrpSpPr/>
+        <p:nvPr/>
+      </p:nvGrpSpPr>
+      <p:grpSpPr>
+        <a:xfrm>
+          <a:off x="0" y="0"/>
+          <a:ext cx="0" cy="0"/>
+          <a:chOff x="0" y="0"/>
+          <a:chExt cx="0" cy="0"/>
+        </a:xfrm>
+      </p:grpSpPr>
+      <p:sp>
+        <p:nvSpPr>
+          <p:cNvPr id="2" name="Title 1">
+            <a:extLst>
+              <a:ext uri="{FF2B5EF4-FFF2-40B4-BE49-F238E27FC236}">
+                <a16:creationId xmlns:a16="http://schemas.microsoft.com/office/drawing/2014/main" id="{ED20E160-0F32-1EE6-E0AD-3C9B4061E8C7}"/>
+              </a:ext>
+            </a:extLst>
+          </p:cNvPr>
+          <p:cNvSpPr>
+            <a:spLocks noGrp="1"/>
+          </p:cNvSpPr>
+          <p:nvPr>
+            <p:ph type="title"/>
+          </p:nvPr>
+        </p:nvSpPr>
+        <p:spPr/>
+        <p:txBody>
+          <a:bodyPr/>
+          <a:lstStyle/>
+          <a:p>
+            <a:r>
+              <a:rPr lang="en-US"/>
+              <a:t>Lab 1</a:t>
+            </a:r>
+          </a:p>
+        </p:txBody>
+      </p:sp>
+      <p:sp>
+        <p:nvSpPr>
+          <p:cNvPr id="3" name="Content Placeholder 2">
+            <a:extLst>
+              <a:ext uri="{FF2B5EF4-FFF2-40B4-BE49-F238E27FC236}">
+                <a16:creationId xmlns:a16="http://schemas.microsoft.com/office/drawing/2014/main" id="{5F734E9C-AAA0-10DE-BFCE-49D582275CBC}"/>
+              </a:ext>
+            </a:extLst>
+          </p:cNvPr>
+          <p:cNvSpPr>
+            <a:spLocks noGrp="1"/>
+          </p:cNvSpPr>
+          <p:nvPr>
+            <p:ph idx="1"/>
+          </p:nvPr>
+        </p:nvSpPr>
+        <p:spPr/>
+        <p:txBody>
+          <a:bodyPr vert="horz" lIns="91440" tIns="45720" rIns="91440" bIns="45720" rtlCol="0" anchor="t">
+            <a:normAutofit/>
+          </a:bodyPr>
+          <a:lstStyle/>
+          <a:p>
+            <a:pPr marL="227965" indent="-227965"/>
+            <a:r>
+              <a:rPr lang="en-US" dirty="0">
+                <a:latin typeface="Arial"/>
+                <a:cs typeface="Arial"/>
+              </a:rPr>
+              <a:t>You can now start work on lab 1.</a:t>
+            </a:r>
+          </a:p>
+          <a:p>
+            <a:pPr marL="227965" indent="-227965"/>
+            <a:r>
+              <a:rPr lang="en-US" dirty="0">
+                <a:latin typeface="Arial"/>
+                <a:cs typeface="Arial"/>
+              </a:rPr>
+              <a:t>Go to course canvas module Labs</a:t>
+            </a:r>
+          </a:p>
+          <a:p>
+            <a:pPr marL="227965" indent="-227965"/>
+            <a:r>
+              <a:rPr lang="en-US" dirty="0">
+                <a:latin typeface="Arial"/>
+                <a:cs typeface="Arial"/>
+              </a:rPr>
+              <a:t>Under Lab 1, you will find this presentation for your reference ‘Lab 1 presentation’ and the lab assignment document ‘Lab1’ .</a:t>
+            </a:r>
+          </a:p>
+          <a:p>
+            <a:pPr marL="227965" indent="-227965"/>
+            <a:r>
+              <a:rPr lang="en-US" dirty="0">
+                <a:latin typeface="Arial"/>
+                <a:cs typeface="Arial"/>
+              </a:rPr>
+              <a:t>Follow the instructions in the document to complete your lab.</a:t>
+            </a:r>
+          </a:p>
+          <a:p>
+            <a:pPr marL="227965" indent="-227965"/>
+            <a:r>
+              <a:rPr lang="en-US" dirty="0">
+                <a:solidFill>
+                  <a:schemeClr val="accent1"/>
+                </a:solidFill>
+                <a:latin typeface="Arial"/>
+                <a:cs typeface="Arial"/>
+              </a:rPr>
+              <a:t>Deliverable Dates</a:t>
+            </a:r>
+          </a:p>
+          <a:p>
+            <a:pPr marL="685154" lvl="1" indent="-227965"/>
+            <a:r>
+              <a:rPr lang="en-US" dirty="0">
+                <a:solidFill>
+                  <a:schemeClr val="accent1"/>
+                </a:solidFill>
+                <a:latin typeface="Arial"/>
+                <a:cs typeface="Arial"/>
+              </a:rPr>
+              <a:t>Demo at the start of the next lab session.</a:t>
+            </a:r>
+          </a:p>
+          <a:p>
+            <a:pPr marL="685154" lvl="1" indent="-227965"/>
+            <a:r>
+              <a:rPr lang="en-US" dirty="0">
+                <a:solidFill>
+                  <a:schemeClr val="accent1"/>
+                </a:solidFill>
+                <a:latin typeface="Arial"/>
+                <a:cs typeface="Arial"/>
+              </a:rPr>
+              <a:t>Upload PDF at the start of the next lab session.</a:t>
+            </a:r>
+          </a:p>
+          <a:p>
+            <a:pPr marL="227965" indent="-227965"/>
+            <a:endParaRPr lang="en-US" dirty="0"/>
+          </a:p>
+          <a:p>
+            <a:pPr marL="227965" indent="-227965"/>
+            <a:endParaRPr lang="en-US" sz="2000" dirty="0"/>
+          </a:p>
+        </p:txBody>
+      </p:sp>
+    </p:spTree>
+    <p:extLst>
+      <p:ext uri="{BB962C8B-B14F-4D97-AF65-F5344CB8AC3E}">
+        <p14:creationId xmlns:p14="http://schemas.microsoft.com/office/powerpoint/2010/main" val="4103412256"/>
+      </p:ext>
+    </p:extLst>
+  </p:cSld>
+  <p:clrMapOvr>
+    <a:masterClrMapping/>
+  </p:clrMapOvr>
+</p:sld>
+</file>
+
+<file path=ppt/slides/slide4.xml><?xml version="1.0" encoding="utf-8"?>
+<p:sld xmlns:a="http://schemas.openxmlformats.org/drawingml/2006/main" xmlns:r="http://schemas.openxmlformats.org/officeDocument/2006/relationships" xmlns:p="http://schemas.openxmlformats.org/presentationml/2006/main">
+  <p:cSld>
+    <p:spTree>
+      <p:nvGrpSpPr>
+        <p:cNvPr id="1" name=""/>
+        <p:cNvGrpSpPr/>
+        <p:nvPr/>
+      </p:nvGrpSpPr>
+      <p:grpSpPr>
+        <a:xfrm>
+          <a:off x="0" y="0"/>
+          <a:ext cx="0" cy="0"/>
+          <a:chOff x="0" y="0"/>
+          <a:chExt cx="0" cy="0"/>
+        </a:xfrm>
+      </p:grpSpPr>
+      <p:sp>
+        <p:nvSpPr>
+          <p:cNvPr id="2" name="Title 1">
+            <a:extLst>
+              <a:ext uri="{FF2B5EF4-FFF2-40B4-BE49-F238E27FC236}">
+                <a16:creationId xmlns:a16="http://schemas.microsoft.com/office/drawing/2014/main" id="{F516007F-0163-9E8A-C3A1-AAEB5C5E4173}"/>
+              </a:ext>
+            </a:extLst>
+          </p:cNvPr>
+          <p:cNvSpPr>
+            <a:spLocks noGrp="1"/>
+          </p:cNvSpPr>
+          <p:nvPr>
+            <p:ph type="title"/>
+          </p:nvPr>
+        </p:nvSpPr>
+        <p:spPr/>
+        <p:txBody>
+          <a:bodyPr/>
+          <a:lstStyle/>
+          <a:p>
+            <a:r>
+              <a:rPr lang="en-US"/>
+              <a:t>Lab 1</a:t>
+            </a:r>
+          </a:p>
+        </p:txBody>
+      </p:sp>
+      <p:sp>
+        <p:nvSpPr>
+          <p:cNvPr id="3" name="Content Placeholder 2">
+            <a:extLst>
+              <a:ext uri="{FF2B5EF4-FFF2-40B4-BE49-F238E27FC236}">
+                <a16:creationId xmlns:a16="http://schemas.microsoft.com/office/drawing/2014/main" id="{30FEAD18-C648-BDE0-AFC2-66812AF32238}"/>
+              </a:ext>
+            </a:extLst>
+          </p:cNvPr>
+          <p:cNvSpPr>
+            <a:spLocks noGrp="1"/>
+          </p:cNvSpPr>
+          <p:nvPr>
+            <p:ph idx="1"/>
+          </p:nvPr>
+        </p:nvSpPr>
+        <p:spPr/>
+        <p:txBody>
+          <a:bodyPr/>
+          <a:lstStyle/>
+          <a:p>
+            <a:r>
+              <a:rPr lang="en-US"/>
+              <a:t>As you complete the ‘how to’ at the start of this lab, you will find that you have already completed part1 of Lab 1: a 2-input AND gate!</a:t>
+            </a:r>
+          </a:p>
+          <a:p>
+            <a:endParaRPr lang="en-US"/>
+          </a:p>
+        </p:txBody>
+      </p:sp>
+    </p:spTree>
+    <p:extLst>
+      <p:ext uri="{BB962C8B-B14F-4D97-AF65-F5344CB8AC3E}">
+        <p14:creationId xmlns:p14="http://schemas.microsoft.com/office/powerpoint/2010/main" val="1418990797"/>
+      </p:ext>
+    </p:extLst>
+  </p:cSld>
+  <p:clrMapOvr>
+    <a:masterClrMapping/>
+  </p:clrMapOvr>
+</p:sld>
+</file>
+
 <file path=ppt/slides/slide5.xml><?xml version="1.0" encoding="utf-8"?>
 <p:sld xmlns:a="http://schemas.openxmlformats.org/drawingml/2006/main" xmlns:r="http://schemas.openxmlformats.org/officeDocument/2006/relationships" xmlns:p="http://schemas.openxmlformats.org/presentationml/2006/main">
   <p:cSld>
@@ -7207,7 +8405,7 @@
           <a:lstStyle/>
           <a:p>
             <a:r>
-              <a:rPr lang="en-US" dirty="0"/>
+              <a:rPr lang="en-US"/>
               <a:t>Building and testing digital circuits</a:t>
             </a:r>
           </a:p>
@@ -7236,25 +8434,25 @@
           <a:lstStyle/>
           <a:p>
             <a:r>
-              <a:rPr lang="en-US" dirty="0"/>
+              <a:rPr lang="en-US"/>
               <a:t>2 files</a:t>
             </a:r>
           </a:p>
           <a:p>
             <a:pPr lvl="1"/>
             <a:r>
-              <a:rPr lang="en-US" dirty="0"/>
+              <a:rPr lang="en-US"/>
               <a:t>Digital circuit	function02.v		Logic for circuit</a:t>
             </a:r>
           </a:p>
           <a:p>
             <a:pPr lvl="1"/>
             <a:r>
-              <a:rPr lang="en-US" dirty="0" err="1"/>
+              <a:rPr lang="en-US" err="1"/>
               <a:t>Testbench</a:t>
             </a:r>
             <a:r>
-              <a:rPr lang="en-US" dirty="0"/>
+              <a:rPr lang="en-US"/>
               <a:t>	function02_tb.v	Test inputs for circuit</a:t>
             </a:r>
           </a:p>
@@ -7262,7 +8460,7 @@
             <a:pPr marL="0" indent="0">
               <a:buNone/>
             </a:pPr>
-            <a:endParaRPr lang="en-US" sz="2800" dirty="0"/>
+            <a:endParaRPr lang="en-US" sz="2800"/>
           </a:p>
         </p:txBody>
       </p:sp>
@@ -7342,7 +8540,7 @@
           <a:lstStyle/>
           <a:p>
             <a:r>
-              <a:rPr lang="en-US" dirty="0"/>
+              <a:rPr lang="en-US"/>
               <a:t>Circuit – code for gates</a:t>
             </a:r>
           </a:p>
@@ -7371,7 +8569,7 @@
           <a:lstStyle/>
           <a:p>
             <a:r>
-              <a:rPr lang="en-US" dirty="0"/>
+              <a:rPr lang="en-US"/>
               <a:t>Concurrent assignment statements</a:t>
             </a:r>
           </a:p>
@@ -7380,7 +8578,7 @@
               <a:buNone/>
             </a:pPr>
             <a:r>
-              <a:rPr lang="en-US" dirty="0">
+              <a:rPr lang="en-US">
                 <a:latin typeface="Courier New" panose="02070309020205020404" pitchFamily="49" charset="0"/>
                 <a:cs typeface="Courier New" panose="02070309020205020404" pitchFamily="49" charset="0"/>
               </a:rPr>
@@ -7392,7 +8590,7 @@
               <a:buNone/>
             </a:pPr>
             <a:r>
-              <a:rPr lang="en-US" dirty="0">
+              <a:rPr lang="en-US">
                 <a:latin typeface="Courier New" panose="02070309020205020404" pitchFamily="49" charset="0"/>
                 <a:cs typeface="Courier New" panose="02070309020205020404" pitchFamily="49" charset="0"/>
               </a:rPr>
@@ -7404,7 +8602,7 @@
               <a:buNone/>
             </a:pPr>
             <a:r>
-              <a:rPr lang="en-US" dirty="0">
+              <a:rPr lang="en-US">
                 <a:latin typeface="Courier New" panose="02070309020205020404" pitchFamily="49" charset="0"/>
                 <a:cs typeface="Courier New" panose="02070309020205020404" pitchFamily="49" charset="0"/>
               </a:rPr>
@@ -7416,7 +8614,7 @@
               <a:buNone/>
             </a:pPr>
             <a:r>
-              <a:rPr lang="en-US" dirty="0">
+              <a:rPr lang="en-US">
                 <a:latin typeface="Courier New" panose="02070309020205020404" pitchFamily="49" charset="0"/>
                 <a:cs typeface="Courier New" panose="02070309020205020404" pitchFamily="49" charset="0"/>
               </a:rPr>
@@ -7428,7 +8626,7 @@
               <a:buNone/>
             </a:pPr>
             <a:r>
-              <a:rPr lang="en-US" dirty="0">
+              <a:rPr lang="en-US">
                 <a:latin typeface="Courier New" panose="02070309020205020404" pitchFamily="49" charset="0"/>
                 <a:cs typeface="Courier New" panose="02070309020205020404" pitchFamily="49" charset="0"/>
               </a:rPr>
@@ -7436,28 +8634,28 @@
             </a:r>
           </a:p>
           <a:p>
-            <a:endParaRPr lang="en-US" dirty="0"/>
-          </a:p>
-          <a:p>
-            <a:r>
-              <a:rPr lang="en-US" dirty="0"/>
+            <a:endParaRPr lang="en-US"/>
+          </a:p>
+          <a:p>
+            <a:r>
+              <a:rPr lang="en-US"/>
               <a:t>All lines of code happen at the same time		concurrent</a:t>
             </a:r>
           </a:p>
           <a:p>
             <a:r>
-              <a:rPr lang="en-US" dirty="0"/>
+              <a:rPr lang="en-US"/>
               <a:t>All lines of code happen all the time			continuous</a:t>
             </a:r>
           </a:p>
           <a:p>
-            <a:endParaRPr lang="en-US" dirty="0"/>
+            <a:endParaRPr lang="en-US"/>
           </a:p>
           <a:p>
             <a:pPr marL="0" indent="0">
               <a:buNone/>
             </a:pPr>
-            <a:endParaRPr lang="en-US" sz="2800" dirty="0"/>
+            <a:endParaRPr lang="en-US" sz="2800"/>
           </a:p>
         </p:txBody>
       </p:sp>
@@ -7507,11 +8705,11 @@
           <a:lstStyle/>
           <a:p>
             <a:r>
-              <a:rPr lang="en-US" dirty="0" err="1"/>
+              <a:rPr lang="en-US" err="1"/>
               <a:t>Testbench</a:t>
             </a:r>
             <a:r>
-              <a:rPr lang="en-US" dirty="0"/>
+              <a:rPr lang="en-US"/>
               <a:t> – driving inputs to circuit</a:t>
             </a:r>
           </a:p>
@@ -7593,11 +8791,11 @@
           <a:lstStyle/>
           <a:p>
             <a:r>
-              <a:rPr lang="en-US" dirty="0" err="1"/>
+              <a:rPr lang="en-US" err="1"/>
               <a:t>Testbench</a:t>
             </a:r>
             <a:r>
-              <a:rPr lang="en-US" dirty="0"/>
+              <a:rPr lang="en-US"/>
               <a:t> – instantiation of test circuit</a:t>
             </a:r>
           </a:p>
@@ -7679,7 +8877,7 @@
           <a:lstStyle/>
           <a:p>
             <a:r>
-              <a:rPr lang="en-US" dirty="0"/>
+              <a:rPr lang="en-US"/>
               <a:t>Circuit - output</a:t>
             </a:r>
           </a:p>
@@ -7708,47 +8906,47 @@
           <a:lstStyle/>
           <a:p>
             <a:r>
-              <a:rPr lang="en-US" dirty="0"/>
+              <a:rPr lang="en-US"/>
               <a:t>Timing diagram – logic level vs. time</a:t>
             </a:r>
           </a:p>
           <a:p>
-            <a:endParaRPr lang="en-US" dirty="0"/>
-          </a:p>
-          <a:p>
-            <a:endParaRPr lang="en-US" dirty="0"/>
-          </a:p>
-          <a:p>
-            <a:endParaRPr lang="en-US" dirty="0"/>
-          </a:p>
-          <a:p>
-            <a:endParaRPr lang="en-US" dirty="0"/>
-          </a:p>
-          <a:p>
-            <a:endParaRPr lang="en-US" dirty="0"/>
+            <a:endParaRPr lang="en-US"/>
+          </a:p>
+          <a:p>
+            <a:endParaRPr lang="en-US"/>
+          </a:p>
+          <a:p>
+            <a:endParaRPr lang="en-US"/>
+          </a:p>
+          <a:p>
+            <a:endParaRPr lang="en-US"/>
+          </a:p>
+          <a:p>
+            <a:endParaRPr lang="en-US"/>
           </a:p>
           <a:p>
             <a:pPr marL="0" indent="0">
               <a:buNone/>
             </a:pPr>
             <a:r>
-              <a:rPr lang="en-US" dirty="0"/>
+              <a:rPr lang="en-US"/>
               <a:t>(</a:t>
             </a:r>
             <a:r>
-              <a:rPr lang="en-US" dirty="0" err="1"/>
+              <a:rPr lang="en-US" err="1"/>
               <a:t>a,b,c</a:t>
             </a:r>
             <a:r>
-              <a:rPr lang="en-US" dirty="0"/>
+              <a:rPr lang="en-US"/>
               <a:t>) = (1,1,0) what is f equal?      Yes, f is the bottom trace.</a:t>
             </a:r>
           </a:p>
           <a:p>
-            <a:endParaRPr lang="en-US" dirty="0"/>
-          </a:p>
-          <a:p>
-            <a:endParaRPr lang="en-US" dirty="0"/>
+            <a:endParaRPr lang="en-US"/>
+          </a:p>
+          <a:p>
+            <a:endParaRPr lang="en-US"/>
           </a:p>
         </p:txBody>
       </p:sp>
@@ -8619,4 +9817,192 @@
     </a:ext>
   </a:extLst>
 </a:theme>
+</file>
+
+<file path=customXml/item1.xml><?xml version="1.0" encoding="utf-8"?>
+<?mso-contentType ?>
+<FormTemplates xmlns="http://schemas.microsoft.com/sharepoint/v3/contenttype/forms">
+  <Display>DocumentLibraryForm</Display>
+  <Edit>DocumentLibraryForm</Edit>
+  <New>DocumentLibraryForm</New>
+</FormTemplates>
+</file>
+
+<file path=customXml/item2.xml><?xml version="1.0" encoding="utf-8"?>
+<p:properties xmlns:p="http://schemas.microsoft.com/office/2006/metadata/properties" xmlns:xsi="http://www.w3.org/2001/XMLSchema-instance" xmlns:pc="http://schemas.microsoft.com/office/infopath/2007/PartnerControls">
+  <documentManagement/>
+</p:properties>
+</file>
+
+<file path=customXml/item3.xml><?xml version="1.0" encoding="utf-8"?>
+<ct:contentTypeSchema xmlns:ct="http://schemas.microsoft.com/office/2006/metadata/contentType" xmlns:ma="http://schemas.microsoft.com/office/2006/metadata/properties/metaAttributes" ct:_="" ma:_="" ma:contentTypeName="Document" ma:contentTypeID="0x010100B0CA56346D718341AD6F7BE32044DEA3" ma:contentTypeVersion="3" ma:contentTypeDescription="Create a new document." ma:contentTypeScope="" ma:versionID="291df287ff1ec43df0b312dda8e1454e">
+  <xsd:schema xmlns:xsd="http://www.w3.org/2001/XMLSchema" xmlns:xs="http://www.w3.org/2001/XMLSchema" xmlns:p="http://schemas.microsoft.com/office/2006/metadata/properties" xmlns:ns2="e54ece5e-ea3e-475a-a07c-9da9db720c35" targetNamespace="http://schemas.microsoft.com/office/2006/metadata/properties" ma:root="true" ma:fieldsID="2af1a4df17c9c95860ef326849b47e11" ns2:_="">
+    <xsd:import namespace="e54ece5e-ea3e-475a-a07c-9da9db720c35"/>
+    <xsd:element name="properties">
+      <xsd:complexType>
+        <xsd:sequence>
+          <xsd:element name="documentManagement">
+            <xsd:complexType>
+              <xsd:all>
+                <xsd:element ref="ns2:MediaServiceMetadata" minOccurs="0"/>
+                <xsd:element ref="ns2:MediaServiceFastMetadata" minOccurs="0"/>
+                <xsd:element ref="ns2:MediaServiceSearchProperties" minOccurs="0"/>
+              </xsd:all>
+            </xsd:complexType>
+          </xsd:element>
+        </xsd:sequence>
+      </xsd:complexType>
+    </xsd:element>
+  </xsd:schema>
+  <xsd:schema xmlns:xsd="http://www.w3.org/2001/XMLSchema" xmlns:xs="http://www.w3.org/2001/XMLSchema" xmlns:dms="http://schemas.microsoft.com/office/2006/documentManagement/types" xmlns:pc="http://schemas.microsoft.com/office/infopath/2007/PartnerControls" targetNamespace="e54ece5e-ea3e-475a-a07c-9da9db720c35" elementFormDefault="qualified">
+    <xsd:import namespace="http://schemas.microsoft.com/office/2006/documentManagement/types"/>
+    <xsd:import namespace="http://schemas.microsoft.com/office/infopath/2007/PartnerControls"/>
+    <xsd:element name="MediaServiceMetadata" ma:index="8" nillable="true" ma:displayName="MediaServiceMetadata" ma:hidden="true" ma:internalName="MediaServiceMetadata" ma:readOnly="true">
+      <xsd:simpleType>
+        <xsd:restriction base="dms:Note"/>
+      </xsd:simpleType>
+    </xsd:element>
+    <xsd:element name="MediaServiceFastMetadata" ma:index="9" nillable="true" ma:displayName="MediaServiceFastMetadata" ma:hidden="true" ma:internalName="MediaServiceFastMetadata" ma:readOnly="true">
+      <xsd:simpleType>
+        <xsd:restriction base="dms:Note"/>
+      </xsd:simpleType>
+    </xsd:element>
+    <xsd:element name="MediaServiceSearchProperties" ma:index="10" nillable="true" ma:displayName="MediaServiceSearchProperties" ma:hidden="true" ma:internalName="MediaServiceSearchProperties" ma:readOnly="true">
+      <xsd:simpleType>
+        <xsd:restriction base="dms:Note"/>
+      </xsd:simpleType>
+    </xsd:element>
+  </xsd:schema>
+  <xsd:schema xmlns="http://schemas.openxmlformats.org/package/2006/metadata/core-properties" xmlns:xsd="http://www.w3.org/2001/XMLSchema" xmlns:xsi="http://www.w3.org/2001/XMLSchema-instance" xmlns:dc="http://purl.org/dc/elements/1.1/" xmlns:dcterms="http://purl.org/dc/terms/" xmlns:odoc="http://schemas.microsoft.com/internal/obd" targetNamespace="http://schemas.openxmlformats.org/package/2006/metadata/core-properties" elementFormDefault="qualified" attributeFormDefault="unqualified" blockDefault="#all">
+    <xsd:import namespace="http://purl.org/dc/elements/1.1/" schemaLocation="http://dublincore.org/schemas/xmls/qdc/2003/04/02/dc.xsd"/>
+    <xsd:import namespace="http://purl.org/dc/terms/" schemaLocation="http://dublincore.org/schemas/xmls/qdc/2003/04/02/dcterms.xsd"/>
+    <xsd:element name="coreProperties" type="CT_coreProperties"/>
+    <xsd:complexType name="CT_coreProperties">
+      <xsd:all>
+        <xsd:element ref="dc:creator" minOccurs="0" maxOccurs="1"/>
+        <xsd:element ref="dcterms:created" minOccurs="0" maxOccurs="1"/>
+        <xsd:element ref="dc:identifier" minOccurs="0" maxOccurs="1"/>
+        <xsd:element name="contentType" minOccurs="0" maxOccurs="1" type="xsd:string" ma:index="0" ma:displayName="Content Type"/>
+        <xsd:element ref="dc:title" minOccurs="0" maxOccurs="1" ma:index="4" ma:displayName="Title"/>
+        <xsd:element ref="dc:subject" minOccurs="0" maxOccurs="1"/>
+        <xsd:element ref="dc:description" minOccurs="0" maxOccurs="1"/>
+        <xsd:element name="keywords" minOccurs="0" maxOccurs="1" type="xsd:string"/>
+        <xsd:element ref="dc:language" minOccurs="0" maxOccurs="1"/>
+        <xsd:element name="category" minOccurs="0" maxOccurs="1" type="xsd:string"/>
+        <xsd:element name="version" minOccurs="0" maxOccurs="1" type="xsd:string"/>
+        <xsd:element name="revision" minOccurs="0" maxOccurs="1" type="xsd:string">
+          <xsd:annotation>
+            <xsd:documentation>
+                        This value indicates the number of saves or revisions. The application is responsible for updating this value after each revision.
+                    </xsd:documentation>
+          </xsd:annotation>
+        </xsd:element>
+        <xsd:element name="lastModifiedBy" minOccurs="0" maxOccurs="1" type="xsd:string"/>
+        <xsd:element ref="dcterms:modified" minOccurs="0" maxOccurs="1"/>
+        <xsd:element name="contentStatus" minOccurs="0" maxOccurs="1" type="xsd:string"/>
+      </xsd:all>
+    </xsd:complexType>
+  </xsd:schema>
+  <xs:schema xmlns:pc="http://schemas.microsoft.com/office/infopath/2007/PartnerControls" xmlns:xs="http://www.w3.org/2001/XMLSchema" targetNamespace="http://schemas.microsoft.com/office/infopath/2007/PartnerControls" elementFormDefault="qualified" attributeFormDefault="unqualified">
+    <xs:element name="Person">
+      <xs:complexType>
+        <xs:sequence>
+          <xs:element ref="pc:DisplayName" minOccurs="0"/>
+          <xs:element ref="pc:AccountId" minOccurs="0"/>
+          <xs:element ref="pc:AccountType" minOccurs="0"/>
+        </xs:sequence>
+      </xs:complexType>
+    </xs:element>
+    <xs:element name="DisplayName" type="xs:string"/>
+    <xs:element name="AccountId" type="xs:string"/>
+    <xs:element name="AccountType" type="xs:string"/>
+    <xs:element name="BDCAssociatedEntity">
+      <xs:complexType>
+        <xs:sequence>
+          <xs:element ref="pc:BDCEntity" minOccurs="0" maxOccurs="unbounded"/>
+        </xs:sequence>
+        <xs:attribute ref="pc:EntityNamespace"/>
+        <xs:attribute ref="pc:EntityName"/>
+        <xs:attribute ref="pc:SystemInstanceName"/>
+        <xs:attribute ref="pc:AssociationName"/>
+      </xs:complexType>
+    </xs:element>
+    <xs:attribute name="EntityNamespace" type="xs:string"/>
+    <xs:attribute name="EntityName" type="xs:string"/>
+    <xs:attribute name="SystemInstanceName" type="xs:string"/>
+    <xs:attribute name="AssociationName" type="xs:string"/>
+    <xs:element name="BDCEntity">
+      <xs:complexType>
+        <xs:sequence>
+          <xs:element ref="pc:EntityDisplayName" minOccurs="0"/>
+          <xs:element ref="pc:EntityInstanceReference" minOccurs="0"/>
+          <xs:element ref="pc:EntityId1" minOccurs="0"/>
+          <xs:element ref="pc:EntityId2" minOccurs="0"/>
+          <xs:element ref="pc:EntityId3" minOccurs="0"/>
+          <xs:element ref="pc:EntityId4" minOccurs="0"/>
+          <xs:element ref="pc:EntityId5" minOccurs="0"/>
+        </xs:sequence>
+      </xs:complexType>
+    </xs:element>
+    <xs:element name="EntityDisplayName" type="xs:string"/>
+    <xs:element name="EntityInstanceReference" type="xs:string"/>
+    <xs:element name="EntityId1" type="xs:string"/>
+    <xs:element name="EntityId2" type="xs:string"/>
+    <xs:element name="EntityId3" type="xs:string"/>
+    <xs:element name="EntityId4" type="xs:string"/>
+    <xs:element name="EntityId5" type="xs:string"/>
+    <xs:element name="Terms">
+      <xs:complexType>
+        <xs:sequence>
+          <xs:element ref="pc:TermInfo" minOccurs="0" maxOccurs="unbounded"/>
+        </xs:sequence>
+      </xs:complexType>
+    </xs:element>
+    <xs:element name="TermInfo">
+      <xs:complexType>
+        <xs:sequence>
+          <xs:element ref="pc:TermName" minOccurs="0"/>
+          <xs:element ref="pc:TermId" minOccurs="0"/>
+        </xs:sequence>
+      </xs:complexType>
+    </xs:element>
+    <xs:element name="TermName" type="xs:string"/>
+    <xs:element name="TermId" type="xs:string"/>
+  </xs:schema>
+</ct:contentTypeSchema>
+</file>
+
+<file path=customXml/itemProps1.xml><?xml version="1.0" encoding="utf-8"?>
+<ds:datastoreItem xmlns:ds="http://schemas.openxmlformats.org/officeDocument/2006/customXml" ds:itemID="{8A66605A-10A5-4B3E-9972-037E170105E0}">
+  <ds:schemaRefs>
+    <ds:schemaRef ds:uri="http://schemas.microsoft.com/sharepoint/v3/contenttype/forms"/>
+  </ds:schemaRefs>
+</ds:datastoreItem>
+</file>
+
+<file path=customXml/itemProps2.xml><?xml version="1.0" encoding="utf-8"?>
+<ds:datastoreItem xmlns:ds="http://schemas.openxmlformats.org/officeDocument/2006/customXml" ds:itemID="{71743505-EF63-4C01-B40C-07055BE12B76}">
+  <ds:schemaRefs>
+    <ds:schemaRef ds:uri="http://schemas.microsoft.com/office/2006/metadata/properties"/>
+    <ds:schemaRef ds:uri="http://schemas.microsoft.com/office/infopath/2007/PartnerControls"/>
+  </ds:schemaRefs>
+</ds:datastoreItem>
+</file>
+
+<file path=customXml/itemProps3.xml><?xml version="1.0" encoding="utf-8"?>
+<ds:datastoreItem xmlns:ds="http://schemas.openxmlformats.org/officeDocument/2006/customXml" ds:itemID="{9C82AAE0-D52A-44DA-9C76-59BEFE6B64FD}">
+  <ds:schemaRefs>
+    <ds:schemaRef ds:uri="e54ece5e-ea3e-475a-a07c-9da9db720c35"/>
+    <ds:schemaRef ds:uri="http://purl.org/dc/elements/1.1/"/>
+    <ds:schemaRef ds:uri="http://purl.org/dc/terms/"/>
+    <ds:schemaRef ds:uri="http://schemas.microsoft.com/internal/obd"/>
+    <ds:schemaRef ds:uri="http://schemas.microsoft.com/office/2006/documentManagement/types"/>
+    <ds:schemaRef ds:uri="http://schemas.microsoft.com/office/2006/metadata/contentType"/>
+    <ds:schemaRef ds:uri="http://schemas.microsoft.com/office/2006/metadata/properties"/>
+    <ds:schemaRef ds:uri="http://schemas.microsoft.com/office/2006/metadata/properties/metaAttributes"/>
+    <ds:schemaRef ds:uri="http://schemas.microsoft.com/office/infopath/2007/PartnerControls"/>
+    <ds:schemaRef ds:uri="http://schemas.openxmlformats.org/package/2006/metadata/core-properties"/>
+    <ds:schemaRef ds:uri="http://www.w3.org/2001/XMLSchema"/>
+  </ds:schemaRefs>
+</ds:datastoreItem>
 </file>
</xml_diff>